<commit_message>
Update docs, untrack pptx modifier file, remove timers
</commit_message>
<xml_diff>
--- a/docs/assets/Caroline_drawings.pptx
+++ b/docs/assets/Caroline_drawings.pptx
@@ -260,7 +260,7 @@
           <a:p>
             <a:fld id="{9BFBA175-CEA6-974F-BECD-C1A384BB3024}" type="datetimeFigureOut">
               <a:rPr lang="en-US" smtClean="0"/>
-              <a:t>7/3/25</a:t>
+              <a:t>3/30/26</a:t>
             </a:fld>
             <a:endParaRPr lang="en-US"/>
           </a:p>
@@ -458,7 +458,7 @@
           <a:p>
             <a:fld id="{9BFBA175-CEA6-974F-BECD-C1A384BB3024}" type="datetimeFigureOut">
               <a:rPr lang="en-US" smtClean="0"/>
-              <a:t>7/3/25</a:t>
+              <a:t>3/30/26</a:t>
             </a:fld>
             <a:endParaRPr lang="en-US"/>
           </a:p>
@@ -666,7 +666,7 @@
           <a:p>
             <a:fld id="{9BFBA175-CEA6-974F-BECD-C1A384BB3024}" type="datetimeFigureOut">
               <a:rPr lang="en-US" smtClean="0"/>
-              <a:t>7/3/25</a:t>
+              <a:t>3/30/26</a:t>
             </a:fld>
             <a:endParaRPr lang="en-US"/>
           </a:p>
@@ -864,7 +864,7 @@
           <a:p>
             <a:fld id="{9BFBA175-CEA6-974F-BECD-C1A384BB3024}" type="datetimeFigureOut">
               <a:rPr lang="en-US" smtClean="0"/>
-              <a:t>7/3/25</a:t>
+              <a:t>3/30/26</a:t>
             </a:fld>
             <a:endParaRPr lang="en-US"/>
           </a:p>
@@ -1139,7 +1139,7 @@
           <a:p>
             <a:fld id="{9BFBA175-CEA6-974F-BECD-C1A384BB3024}" type="datetimeFigureOut">
               <a:rPr lang="en-US" smtClean="0"/>
-              <a:t>7/3/25</a:t>
+              <a:t>3/30/26</a:t>
             </a:fld>
             <a:endParaRPr lang="en-US"/>
           </a:p>
@@ -1404,7 +1404,7 @@
           <a:p>
             <a:fld id="{9BFBA175-CEA6-974F-BECD-C1A384BB3024}" type="datetimeFigureOut">
               <a:rPr lang="en-US" smtClean="0"/>
-              <a:t>7/3/25</a:t>
+              <a:t>3/30/26</a:t>
             </a:fld>
             <a:endParaRPr lang="en-US"/>
           </a:p>
@@ -1816,7 +1816,7 @@
           <a:p>
             <a:fld id="{9BFBA175-CEA6-974F-BECD-C1A384BB3024}" type="datetimeFigureOut">
               <a:rPr lang="en-US" smtClean="0"/>
-              <a:t>7/3/25</a:t>
+              <a:t>3/30/26</a:t>
             </a:fld>
             <a:endParaRPr lang="en-US"/>
           </a:p>
@@ -1957,7 +1957,7 @@
           <a:p>
             <a:fld id="{9BFBA175-CEA6-974F-BECD-C1A384BB3024}" type="datetimeFigureOut">
               <a:rPr lang="en-US" smtClean="0"/>
-              <a:t>7/3/25</a:t>
+              <a:t>3/30/26</a:t>
             </a:fld>
             <a:endParaRPr lang="en-US"/>
           </a:p>
@@ -2070,7 +2070,7 @@
           <a:p>
             <a:fld id="{9BFBA175-CEA6-974F-BECD-C1A384BB3024}" type="datetimeFigureOut">
               <a:rPr lang="en-US" smtClean="0"/>
-              <a:t>7/3/25</a:t>
+              <a:t>3/30/26</a:t>
             </a:fld>
             <a:endParaRPr lang="en-US"/>
           </a:p>
@@ -2381,7 +2381,7 @@
           <a:p>
             <a:fld id="{9BFBA175-CEA6-974F-BECD-C1A384BB3024}" type="datetimeFigureOut">
               <a:rPr lang="en-US" smtClean="0"/>
-              <a:t>7/3/25</a:t>
+              <a:t>3/30/26</a:t>
             </a:fld>
             <a:endParaRPr lang="en-US"/>
           </a:p>
@@ -2669,7 +2669,7 @@
           <a:p>
             <a:fld id="{9BFBA175-CEA6-974F-BECD-C1A384BB3024}" type="datetimeFigureOut">
               <a:rPr lang="en-US" smtClean="0"/>
-              <a:t>7/3/25</a:t>
+              <a:t>3/30/26</a:t>
             </a:fld>
             <a:endParaRPr lang="en-US"/>
           </a:p>
@@ -2910,7 +2910,7 @@
           <a:p>
             <a:fld id="{9BFBA175-CEA6-974F-BECD-C1A384BB3024}" type="datetimeFigureOut">
               <a:rPr lang="en-US" smtClean="0"/>
-              <a:t>7/3/25</a:t>
+              <a:t>3/30/26</a:t>
             </a:fld>
             <a:endParaRPr lang="en-US"/>
           </a:p>
@@ -3828,10 +3828,10 @@
           <p:nvPr/>
         </p:nvPicPr>
         <p:blipFill>
-          <a:blip r:embed="rId2">
+          <a:blip>
             <a:extLst>
               <a:ext uri="{96DAC541-7B7A-43D3-8B79-37D633B846F1}">
-                <asvg:svgBlip xmlns:asvg="http://schemas.microsoft.com/office/drawing/2016/SVG/main" r:embed="rId3"/>
+                <asvg:svgBlip xmlns:asvg="http://schemas.microsoft.com/office/drawing/2016/SVG/main" r:embed="rId2"/>
               </a:ext>
             </a:extLst>
           </a:blip>
@@ -3863,8 +3863,8 @@
         </p:nvSpPr>
         <p:spPr>
           <a:xfrm>
-            <a:off x="3296839" y="1424480"/>
-            <a:ext cx="1442598" cy="1607580"/>
+            <a:off x="3296838" y="1085850"/>
+            <a:ext cx="1711127" cy="2083340"/>
           </a:xfrm>
           <a:prstGeom prst="rect">
             <a:avLst/>
@@ -4003,7 +4003,7 @@
         <p:spPr>
           <a:xfrm>
             <a:off x="1361938" y="414893"/>
-            <a:ext cx="1843837" cy="276998"/>
+            <a:ext cx="1531683" cy="276998"/>
           </a:xfrm>
           <a:prstGeom prst="rect">
             <a:avLst/>
@@ -4090,10 +4090,10 @@
           <p:nvPr/>
         </p:nvPicPr>
         <p:blipFill>
-          <a:blip r:embed="rId2">
+          <a:blip>
             <a:extLst>
               <a:ext uri="{96DAC541-7B7A-43D3-8B79-37D633B846F1}">
-                <asvg:svgBlip xmlns:asvg="http://schemas.microsoft.com/office/drawing/2016/SVG/main" r:embed="rId3"/>
+                <asvg:svgBlip xmlns:asvg="http://schemas.microsoft.com/office/drawing/2016/SVG/main" r:embed="rId2"/>
               </a:ext>
             </a:extLst>
           </a:blip>
@@ -4176,13 +4176,13 @@
         <p:spPr>
           <a:xfrm flipH="1">
             <a:off x="959222" y="553392"/>
-            <a:ext cx="2246553" cy="1460405"/>
+            <a:ext cx="1934399" cy="1460405"/>
           </a:xfrm>
           <a:prstGeom prst="bentConnector5">
             <a:avLst>
-              <a:gd name="adj1" fmla="val -2036"/>
-              <a:gd name="adj2" fmla="val 22978"/>
-              <a:gd name="adj3" fmla="val 116174"/>
+              <a:gd name="adj1" fmla="val -11818"/>
+              <a:gd name="adj2" fmla="val 15650"/>
+              <a:gd name="adj3" fmla="val 121009"/>
             </a:avLst>
           </a:prstGeom>
           <a:ln w="38100">
@@ -4218,8 +4218,8 @@
         </p:nvSpPr>
         <p:spPr>
           <a:xfrm>
-            <a:off x="3470650" y="1864660"/>
-            <a:ext cx="740163" cy="276998"/>
+            <a:off x="3411989" y="1515410"/>
+            <a:ext cx="678174" cy="276998"/>
           </a:xfrm>
           <a:prstGeom prst="rect">
             <a:avLst/>
@@ -4270,8 +4270,43 @@
         </p:nvSpPr>
         <p:spPr>
           <a:xfrm>
-            <a:off x="3442808" y="1867422"/>
-            <a:ext cx="538930" cy="276999"/>
+            <a:off x="3425942" y="1518172"/>
+            <a:ext cx="662644" cy="276999"/>
+          </a:xfrm>
+          <a:prstGeom prst="rect">
+            <a:avLst/>
+          </a:prstGeom>
+          <a:noFill/>
+        </p:spPr>
+        <p:txBody>
+          <a:bodyPr wrap="square" rtlCol="0">
+            <a:spAutoFit/>
+          </a:bodyPr>
+          <a:lstStyle/>
+          <a:p>
+            <a:r>
+              <a:rPr lang="en-US" sz="1200" noProof="1"/>
+              <a:t>Doris</a:t>
+            </a:r>
+          </a:p>
+        </p:txBody>
+      </p:sp>
+      <p:sp>
+        <p:nvSpPr>
+          <p:cNvPr id="39" name="TextBox 38">
+            <a:extLst>
+              <a:ext uri="{FF2B5EF4-FFF2-40B4-BE49-F238E27FC236}">
+                <a16:creationId xmlns:a16="http://schemas.microsoft.com/office/drawing/2014/main" id="{538E1BAF-01BE-3173-DF7A-A11580DA9B1A}"/>
+              </a:ext>
+            </a:extLst>
+          </p:cNvPr>
+          <p:cNvSpPr txBox="1"/>
+          <p:nvPr/>
+        </p:nvSpPr>
+        <p:spPr>
+          <a:xfrm>
+            <a:off x="3229998" y="1062000"/>
+            <a:ext cx="1158394" cy="461665"/>
           </a:xfrm>
           <a:prstGeom prst="rect">
             <a:avLst/>
@@ -4286,41 +4321,6 @@
           <a:p>
             <a:r>
               <a:rPr lang="en-US" sz="1200" noProof="1"/>
-              <a:t>Doris</a:t>
-            </a:r>
-          </a:p>
-        </p:txBody>
-      </p:sp>
-      <p:sp>
-        <p:nvSpPr>
-          <p:cNvPr id="39" name="TextBox 38">
-            <a:extLst>
-              <a:ext uri="{FF2B5EF4-FFF2-40B4-BE49-F238E27FC236}">
-                <a16:creationId xmlns:a16="http://schemas.microsoft.com/office/drawing/2014/main" id="{538E1BAF-01BE-3173-DF7A-A11580DA9B1A}"/>
-              </a:ext>
-            </a:extLst>
-          </p:cNvPr>
-          <p:cNvSpPr txBox="1"/>
-          <p:nvPr/>
-        </p:nvSpPr>
-        <p:spPr>
-          <a:xfrm>
-            <a:off x="3293181" y="1424479"/>
-            <a:ext cx="1158394" cy="461665"/>
-          </a:xfrm>
-          <a:prstGeom prst="rect">
-            <a:avLst/>
-          </a:prstGeom>
-          <a:noFill/>
-        </p:spPr>
-        <p:txBody>
-          <a:bodyPr wrap="none" rtlCol="0">
-            <a:spAutoFit/>
-          </a:bodyPr>
-          <a:lstStyle/>
-          <a:p>
-            <a:r>
-              <a:rPr lang="en-US" sz="1200" noProof="1"/>
               <a:t>Coregistration </a:t>
             </a:r>
           </a:p>
@@ -4346,7 +4346,7 @@
         </p:nvSpPr>
         <p:spPr>
           <a:xfrm>
-            <a:off x="3454713" y="2671936"/>
+            <a:off x="3416988" y="1858796"/>
             <a:ext cx="763801" cy="276998"/>
           </a:xfrm>
           <a:prstGeom prst="rect">
@@ -4398,8 +4398,8 @@
         </p:nvSpPr>
         <p:spPr>
           <a:xfrm>
-            <a:off x="3454712" y="2671935"/>
-            <a:ext cx="760144" cy="276999"/>
+            <a:off x="3427119" y="1851467"/>
+            <a:ext cx="782189" cy="276999"/>
           </a:xfrm>
           <a:prstGeom prst="rect">
             <a:avLst/>
@@ -4407,7 +4407,7 @@
           <a:noFill/>
         </p:spPr>
         <p:txBody>
-          <a:bodyPr wrap="none" rtlCol="0">
+          <a:bodyPr wrap="square" rtlCol="0">
             <a:spAutoFit/>
           </a:bodyPr>
           <a:lstStyle/>
@@ -4433,8 +4433,8 @@
         </p:nvSpPr>
         <p:spPr>
           <a:xfrm>
-            <a:off x="3454716" y="2256439"/>
-            <a:ext cx="1273195" cy="276998"/>
+            <a:off x="4293638" y="1165679"/>
+            <a:ext cx="681168" cy="387525"/>
           </a:xfrm>
           <a:prstGeom prst="rect">
             <a:avLst/>
@@ -4485,8 +4485,8 @@
         </p:nvSpPr>
         <p:spPr>
           <a:xfrm>
-            <a:off x="3442539" y="2252707"/>
-            <a:ext cx="1467469" cy="276999"/>
+            <a:off x="4266469" y="1132898"/>
+            <a:ext cx="785106" cy="461665"/>
           </a:xfrm>
           <a:prstGeom prst="rect">
             <a:avLst/>
@@ -4501,7 +4501,13 @@
           <a:p>
             <a:r>
               <a:rPr lang="en-US" sz="1200" noProof="1"/>
-              <a:t>Doris_cleanup</a:t>
+              <a:t>Doris_</a:t>
+            </a:r>
+          </a:p>
+          <a:p>
+            <a:r>
+              <a:rPr lang="en-US" sz="1200" noProof="1"/>
+              <a:t>cleanup</a:t>
             </a:r>
           </a:p>
         </p:txBody>
@@ -4524,8 +4530,8 @@
         </p:nvCxnSpPr>
         <p:spPr>
           <a:xfrm flipV="1">
-            <a:off x="2030477" y="2005922"/>
-            <a:ext cx="1412331" cy="7875"/>
+            <a:off x="2030477" y="1656672"/>
+            <a:ext cx="1395465" cy="357125"/>
           </a:xfrm>
           <a:prstGeom prst="bentConnector3">
             <a:avLst>
@@ -4569,12 +4575,12 @@
         </p:nvCxnSpPr>
         <p:spPr>
           <a:xfrm>
-            <a:off x="3205775" y="553392"/>
-            <a:ext cx="248937" cy="2257043"/>
+            <a:off x="2893621" y="553392"/>
+            <a:ext cx="533498" cy="1436575"/>
           </a:xfrm>
           <a:prstGeom prst="bentConnector3">
             <a:avLst>
-              <a:gd name="adj1" fmla="val 15717"/>
+              <a:gd name="adj1" fmla="val 44049"/>
             </a:avLst>
           </a:prstGeom>
           <a:ln w="38100">
@@ -4613,15 +4619,13 @@
           <p:nvPr/>
         </p:nvCxnSpPr>
         <p:spPr>
-          <a:xfrm flipH="1">
-            <a:off x="3442539" y="2005922"/>
-            <a:ext cx="539199" cy="385285"/>
-          </a:xfrm>
-          <a:prstGeom prst="bentConnector5">
+          <a:xfrm flipV="1">
+            <a:off x="4088586" y="1363731"/>
+            <a:ext cx="177883" cy="292941"/>
+          </a:xfrm>
+          <a:prstGeom prst="bentConnector3">
             <a:avLst>
-              <a:gd name="adj1" fmla="val -42396"/>
-              <a:gd name="adj2" fmla="val 50000"/>
-              <a:gd name="adj3" fmla="val 142396"/>
+              <a:gd name="adj1" fmla="val 17873"/>
             </a:avLst>
           </a:prstGeom>
           <a:ln w="38100">
@@ -4657,8 +4661,8 @@
         </p:nvSpPr>
         <p:spPr>
           <a:xfrm>
-            <a:off x="4959049" y="1423746"/>
-            <a:ext cx="1562006" cy="1607580"/>
+            <a:off x="5185847" y="1423746"/>
+            <a:ext cx="1335208" cy="1607580"/>
           </a:xfrm>
           <a:prstGeom prst="rect">
             <a:avLst/>
@@ -4709,8 +4713,8 @@
         </p:nvSpPr>
         <p:spPr>
           <a:xfrm>
-            <a:off x="5041715" y="1871922"/>
-            <a:ext cx="1370035" cy="276998"/>
+            <a:off x="5276654" y="1871922"/>
+            <a:ext cx="1135096" cy="276998"/>
           </a:xfrm>
           <a:prstGeom prst="rect">
             <a:avLst/>
@@ -4761,8 +4765,8 @@
         </p:nvSpPr>
         <p:spPr>
           <a:xfrm>
-            <a:off x="4982546" y="1876997"/>
-            <a:ext cx="1483227" cy="276999"/>
+            <a:off x="5255827" y="1876997"/>
+            <a:ext cx="1155923" cy="276999"/>
           </a:xfrm>
           <a:prstGeom prst="rect">
             <a:avLst/>
@@ -4796,7 +4800,7 @@
         </p:nvSpPr>
         <p:spPr>
           <a:xfrm>
-            <a:off x="4898509" y="1424479"/>
+            <a:off x="5203011" y="1424514"/>
             <a:ext cx="944489" cy="461665"/>
           </a:xfrm>
           <a:prstGeom prst="rect">
@@ -4837,8 +4841,8 @@
         </p:nvSpPr>
         <p:spPr>
           <a:xfrm>
-            <a:off x="5033749" y="2255705"/>
-            <a:ext cx="1390722" cy="276998"/>
+            <a:off x="5278701" y="2255705"/>
+            <a:ext cx="1145770" cy="276998"/>
           </a:xfrm>
           <a:prstGeom prst="rect">
             <a:avLst/>
@@ -4889,8 +4893,8 @@
         </p:nvSpPr>
         <p:spPr>
           <a:xfrm>
-            <a:off x="4993959" y="2263050"/>
-            <a:ext cx="1011367" cy="276999"/>
+            <a:off x="5275043" y="2273990"/>
+            <a:ext cx="1022204" cy="276999"/>
           </a:xfrm>
           <a:prstGeom prst="rect">
             <a:avLst/>
@@ -4898,7 +4902,7 @@
           <a:noFill/>
         </p:spPr>
         <p:txBody>
-          <a:bodyPr wrap="none" rtlCol="0">
+          <a:bodyPr wrap="square" rtlCol="0">
             <a:spAutoFit/>
           </a:bodyPr>
           <a:lstStyle/>
@@ -4928,12 +4932,12 @@
         </p:nvCxnSpPr>
         <p:spPr>
           <a:xfrm>
-            <a:off x="3981738" y="2005922"/>
-            <a:ext cx="1000808" cy="9575"/>
+            <a:off x="4088586" y="1656672"/>
+            <a:ext cx="1167241" cy="358825"/>
           </a:xfrm>
           <a:prstGeom prst="bentConnector3">
             <a:avLst>
-              <a:gd name="adj1" fmla="val 50000"/>
+              <a:gd name="adj1" fmla="val 84817"/>
             </a:avLst>
           </a:prstGeom>
           <a:ln w="38100">
@@ -4973,12 +4977,12 @@
         </p:nvCxnSpPr>
         <p:spPr>
           <a:xfrm>
-            <a:off x="3981738" y="2005922"/>
-            <a:ext cx="1012221" cy="395628"/>
+            <a:off x="4088586" y="1656672"/>
+            <a:ext cx="1186457" cy="755818"/>
           </a:xfrm>
           <a:prstGeom prst="bentConnector3">
             <a:avLst>
-              <a:gd name="adj1" fmla="val 50000"/>
+              <a:gd name="adj1" fmla="val 69267"/>
             </a:avLst>
           </a:prstGeom>
           <a:ln w="38100">
@@ -5017,13 +5021,13 @@
           <p:nvPr/>
         </p:nvCxnSpPr>
         <p:spPr>
-          <a:xfrm flipV="1">
-            <a:off x="4218514" y="2015497"/>
-            <a:ext cx="764032" cy="794938"/>
+          <a:xfrm>
+            <a:off x="4180789" y="1997295"/>
+            <a:ext cx="1075038" cy="18202"/>
           </a:xfrm>
           <a:prstGeom prst="bentConnector3">
             <a:avLst>
-              <a:gd name="adj1" fmla="val 77926"/>
+              <a:gd name="adj1" fmla="val 57679"/>
             </a:avLst>
           </a:prstGeom>
           <a:ln w="38100">
@@ -5062,13 +5066,13 @@
           <p:nvPr/>
         </p:nvCxnSpPr>
         <p:spPr>
-          <a:xfrm flipV="1">
-            <a:off x="4218514" y="2401550"/>
-            <a:ext cx="775445" cy="408885"/>
+          <a:xfrm>
+            <a:off x="4180789" y="1997295"/>
+            <a:ext cx="1094254" cy="415195"/>
           </a:xfrm>
           <a:prstGeom prst="bentConnector3">
             <a:avLst>
-              <a:gd name="adj1" fmla="val 50000"/>
+              <a:gd name="adj1" fmla="val 56383"/>
             </a:avLst>
           </a:prstGeom>
           <a:ln w="38100">
@@ -5494,10 +5498,10 @@
           <p:nvPr/>
         </p:nvPicPr>
         <p:blipFill>
-          <a:blip r:embed="rId2">
+          <a:blip>
             <a:extLst>
               <a:ext uri="{96DAC541-7B7A-43D3-8B79-37D633B846F1}">
-                <asvg:svgBlip xmlns:asvg="http://schemas.microsoft.com/office/drawing/2016/SVG/main" r:embed="rId3"/>
+                <asvg:svgBlip xmlns:asvg="http://schemas.microsoft.com/office/drawing/2016/SVG/main" r:embed="rId2"/>
               </a:ext>
             </a:extLst>
           </a:blip>
@@ -5737,8 +5741,8 @@
         </p:nvCxnSpPr>
         <p:spPr>
           <a:xfrm rot="10800000" flipV="1">
-            <a:off x="5740052" y="423098"/>
-            <a:ext cx="1156262" cy="1000647"/>
+            <a:off x="5853452" y="423098"/>
+            <a:ext cx="1042863" cy="1000647"/>
           </a:xfrm>
           <a:prstGeom prst="bentConnector2">
             <a:avLst/>
@@ -6051,12 +6055,12 @@
         </p:nvCxnSpPr>
         <p:spPr>
           <a:xfrm>
-            <a:off x="6465773" y="2015497"/>
-            <a:ext cx="1287765" cy="408756"/>
+            <a:off x="6411750" y="2015497"/>
+            <a:ext cx="1341788" cy="408756"/>
           </a:xfrm>
           <a:prstGeom prst="bentConnector3">
             <a:avLst>
-              <a:gd name="adj1" fmla="val 34379"/>
+              <a:gd name="adj1" fmla="val 39589"/>
             </a:avLst>
           </a:prstGeom>
           <a:ln w="38100">
@@ -7207,10 +7211,10 @@
           <p:nvPr/>
         </p:nvPicPr>
         <p:blipFill>
-          <a:blip r:embed="rId2">
+          <a:blip>
             <a:extLst>
               <a:ext uri="{96DAC541-7B7A-43D3-8B79-37D633B846F1}">
-                <asvg:svgBlip xmlns:asvg="http://schemas.microsoft.com/office/drawing/2016/SVG/main" r:embed="rId3"/>
+                <asvg:svgBlip xmlns:asvg="http://schemas.microsoft.com/office/drawing/2016/SVG/main" r:embed="rId2"/>
               </a:ext>
             </a:extLst>
           </a:blip>
@@ -8121,139 +8125,10 @@
       </p:sp>
       <p:sp>
         <p:nvSpPr>
-          <p:cNvPr id="235" name="TextBox 234">
-            <a:extLst>
-              <a:ext uri="{FF2B5EF4-FFF2-40B4-BE49-F238E27FC236}">
-                <a16:creationId xmlns:a16="http://schemas.microsoft.com/office/drawing/2014/main" id="{6C41EAC6-8BA9-F9C0-D2B2-B94F85BEEC94}"/>
-              </a:ext>
-            </a:extLst>
-          </p:cNvPr>
-          <p:cNvSpPr txBox="1"/>
-          <p:nvPr/>
-        </p:nvSpPr>
-        <p:spPr>
-          <a:xfrm>
-            <a:off x="2196139" y="6525711"/>
-            <a:ext cx="1678986" cy="276999"/>
-          </a:xfrm>
-          <a:prstGeom prst="rect">
-            <a:avLst/>
-          </a:prstGeom>
-          <a:noFill/>
-        </p:spPr>
-        <p:txBody>
-          <a:bodyPr wrap="none" rtlCol="0">
-            <a:spAutoFit/>
-          </a:bodyPr>
-          <a:lstStyle/>
-          <a:p>
-            <a:r>
-              <a:rPr lang="en-US" sz="1200" noProof="1"/>
-              <a:t>caroline-download.log</a:t>
-            </a:r>
-          </a:p>
-        </p:txBody>
-      </p:sp>
-      <p:cxnSp>
-        <p:nvCxnSpPr>
-          <p:cNvPr id="236" name="Elbow Connector 235">
-            <a:extLst>
-              <a:ext uri="{FF2B5EF4-FFF2-40B4-BE49-F238E27FC236}">
-                <a16:creationId xmlns:a16="http://schemas.microsoft.com/office/drawing/2014/main" id="{E25ECFBC-DD90-6998-C466-10A38D14D511}"/>
-              </a:ext>
-            </a:extLst>
-          </p:cNvPr>
-          <p:cNvCxnSpPr>
-            <a:cxnSpLocks/>
-            <a:stCxn id="24" idx="3"/>
-            <a:endCxn id="233" idx="1"/>
-          </p:cNvCxnSpPr>
-          <p:nvPr/>
-        </p:nvCxnSpPr>
-        <p:spPr>
-          <a:xfrm flipH="1">
-            <a:off x="2212724" y="553392"/>
-            <a:ext cx="993051" cy="5751216"/>
-          </a:xfrm>
-          <a:prstGeom prst="bentConnector5">
-            <a:avLst>
-              <a:gd name="adj1" fmla="val -3613"/>
-              <a:gd name="adj2" fmla="val 47554"/>
-              <a:gd name="adj3" fmla="val 202350"/>
-            </a:avLst>
-          </a:prstGeom>
-          <a:ln w="38100">
-            <a:tailEnd type="triangle"/>
-          </a:ln>
-        </p:spPr>
-        <p:style>
-          <a:lnRef idx="2">
-            <a:schemeClr val="dk1"/>
-          </a:lnRef>
-          <a:fillRef idx="0">
-            <a:schemeClr val="dk1"/>
-          </a:fillRef>
-          <a:effectRef idx="1">
-            <a:schemeClr val="dk1"/>
-          </a:effectRef>
-          <a:fontRef idx="minor">
-            <a:schemeClr val="tx1"/>
-          </a:fontRef>
-        </p:style>
-      </p:cxnSp>
-      <p:cxnSp>
-        <p:nvCxnSpPr>
-          <p:cNvPr id="245" name="Elbow Connector 244">
-            <a:extLst>
-              <a:ext uri="{FF2B5EF4-FFF2-40B4-BE49-F238E27FC236}">
-                <a16:creationId xmlns:a16="http://schemas.microsoft.com/office/drawing/2014/main" id="{2BAB6FC4-08EF-3B2E-4E28-66AC35CA0206}"/>
-              </a:ext>
-            </a:extLst>
-          </p:cNvPr>
-          <p:cNvCxnSpPr>
-            <a:cxnSpLocks/>
-            <a:stCxn id="24" idx="3"/>
-            <a:endCxn id="230" idx="1"/>
-          </p:cNvCxnSpPr>
-          <p:nvPr/>
-        </p:nvCxnSpPr>
-        <p:spPr>
-          <a:xfrm flipH="1">
-            <a:off x="2211057" y="553392"/>
-            <a:ext cx="994718" cy="5419851"/>
-          </a:xfrm>
-          <a:prstGeom prst="bentConnector5">
-            <a:avLst>
-              <a:gd name="adj1" fmla="val -3700"/>
-              <a:gd name="adj2" fmla="val 50513"/>
-              <a:gd name="adj3" fmla="val 200764"/>
-            </a:avLst>
-          </a:prstGeom>
-          <a:ln w="38100">
-            <a:tailEnd type="triangle"/>
-          </a:ln>
-        </p:spPr>
-        <p:style>
-          <a:lnRef idx="2">
-            <a:schemeClr val="dk1"/>
-          </a:lnRef>
-          <a:fillRef idx="0">
-            <a:schemeClr val="dk1"/>
-          </a:fillRef>
-          <a:effectRef idx="1">
-            <a:schemeClr val="dk1"/>
-          </a:effectRef>
-          <a:fontRef idx="minor">
-            <a:schemeClr val="tx1"/>
-          </a:fontRef>
-        </p:style>
-      </p:cxnSp>
-      <p:sp>
-        <p:nvSpPr>
-          <p:cNvPr id="251" name="Rectangle 250">
-            <a:extLst>
-              <a:ext uri="{FF2B5EF4-FFF2-40B4-BE49-F238E27FC236}">
-                <a16:creationId xmlns:a16="http://schemas.microsoft.com/office/drawing/2014/main" id="{0DE18C41-7D69-C3A8-2E4C-550B0C257405}"/>
+          <p:cNvPr id="12" name="Rectangle 11">
+            <a:extLst>
+              <a:ext uri="{FF2B5EF4-FFF2-40B4-BE49-F238E27FC236}">
+                <a16:creationId xmlns:a16="http://schemas.microsoft.com/office/drawing/2014/main" id="{C8E75110-E5A2-86E9-F389-F50AFA3FB93B}"/>
               </a:ext>
             </a:extLst>
           </p:cNvPr>
@@ -8262,16 +8137,15 @@
         </p:nvSpPr>
         <p:spPr>
           <a:xfrm>
-            <a:off x="4241656" y="5820809"/>
-            <a:ext cx="1002645" cy="235607"/>
+            <a:off x="2190654" y="6869131"/>
+            <a:ext cx="1798521" cy="276999"/>
           </a:xfrm>
           <a:prstGeom prst="rect">
             <a:avLst/>
           </a:prstGeom>
           <a:solidFill>
-            <a:schemeClr val="accent2">
-              <a:lumMod val="60000"/>
-              <a:lumOff val="40000"/>
+            <a:schemeClr val="bg2">
+              <a:lumMod val="90000"/>
             </a:schemeClr>
           </a:solidFill>
         </p:spPr>
@@ -8300,48 +8174,12 @@
           </a:p>
         </p:txBody>
       </p:sp>
-      <p:pic>
-        <p:nvPicPr>
-          <p:cNvPr id="252" name="Graphic 251" descr="Repeat with solid fill">
-            <a:extLst>
-              <a:ext uri="{FF2B5EF4-FFF2-40B4-BE49-F238E27FC236}">
-                <a16:creationId xmlns:a16="http://schemas.microsoft.com/office/drawing/2014/main" id="{67A996B4-F823-EC67-0AE1-4EE31A3646EC}"/>
-              </a:ext>
-            </a:extLst>
-          </p:cNvPr>
-          <p:cNvPicPr>
-            <a:picLocks noChangeAspect="1"/>
-          </p:cNvPicPr>
-          <p:nvPr/>
-        </p:nvPicPr>
-        <p:blipFill>
-          <a:blip r:embed="rId2">
-            <a:extLst>
-              <a:ext uri="{96DAC541-7B7A-43D3-8B79-37D633B846F1}">
-                <asvg:svgBlip xmlns:asvg="http://schemas.microsoft.com/office/drawing/2016/SVG/main" r:embed="rId3"/>
-              </a:ext>
-            </a:extLst>
-          </a:blip>
-          <a:stretch>
-            <a:fillRect/>
-          </a:stretch>
-        </p:blipFill>
-        <p:spPr>
-          <a:xfrm>
-            <a:off x="4103691" y="5607275"/>
-            <a:ext cx="366563" cy="366563"/>
-          </a:xfrm>
-          <a:prstGeom prst="rect">
-            <a:avLst/>
-          </a:prstGeom>
-        </p:spPr>
-      </p:pic>
-      <p:sp>
-        <p:nvSpPr>
-          <p:cNvPr id="253" name="TextBox 252">
-            <a:extLst>
-              <a:ext uri="{FF2B5EF4-FFF2-40B4-BE49-F238E27FC236}">
-                <a16:creationId xmlns:a16="http://schemas.microsoft.com/office/drawing/2014/main" id="{7CDEFB63-7160-738C-F4FD-61210C50AEF9}"/>
+      <p:sp>
+        <p:nvSpPr>
+          <p:cNvPr id="235" name="TextBox 234">
+            <a:extLst>
+              <a:ext uri="{FF2B5EF4-FFF2-40B4-BE49-F238E27FC236}">
+                <a16:creationId xmlns:a16="http://schemas.microsoft.com/office/drawing/2014/main" id="{6C41EAC6-8BA9-F9C0-D2B2-B94F85BEEC94}"/>
               </a:ext>
             </a:extLst>
           </p:cNvPr>
@@ -8350,8 +8188,8 @@
         </p:nvSpPr>
         <p:spPr>
           <a:xfrm>
-            <a:off x="4179018" y="5810866"/>
-            <a:ext cx="1011302" cy="276999"/>
+            <a:off x="2196500" y="6869131"/>
+            <a:ext cx="1678986" cy="276999"/>
           </a:xfrm>
           <a:prstGeom prst="rect">
             <a:avLst/>
@@ -8366,17 +8204,111 @@
           <a:p>
             <a:r>
               <a:rPr lang="en-US" sz="1200" noProof="1"/>
-              <a:t>email-log.sh</a:t>
-            </a:r>
-          </a:p>
-        </p:txBody>
-      </p:sp>
-      <p:sp>
-        <p:nvSpPr>
-          <p:cNvPr id="254" name="Rectangle 253">
-            <a:extLst>
-              <a:ext uri="{FF2B5EF4-FFF2-40B4-BE49-F238E27FC236}">
-                <a16:creationId xmlns:a16="http://schemas.microsoft.com/office/drawing/2014/main" id="{1F4EA00B-6D53-7E05-F41D-830F9BDC1505}"/>
+              <a:t>caroline-download.log</a:t>
+            </a:r>
+          </a:p>
+        </p:txBody>
+      </p:sp>
+      <p:cxnSp>
+        <p:nvCxnSpPr>
+          <p:cNvPr id="236" name="Elbow Connector 235">
+            <a:extLst>
+              <a:ext uri="{FF2B5EF4-FFF2-40B4-BE49-F238E27FC236}">
+                <a16:creationId xmlns:a16="http://schemas.microsoft.com/office/drawing/2014/main" id="{E25ECFBC-DD90-6998-C466-10A38D14D511}"/>
+              </a:ext>
+            </a:extLst>
+          </p:cNvPr>
+          <p:cNvCxnSpPr>
+            <a:cxnSpLocks/>
+            <a:stCxn id="24" idx="3"/>
+            <a:endCxn id="233" idx="1"/>
+          </p:cNvCxnSpPr>
+          <p:nvPr/>
+        </p:nvCxnSpPr>
+        <p:spPr>
+          <a:xfrm flipH="1">
+            <a:off x="2212724" y="553392"/>
+            <a:ext cx="680897" cy="5751216"/>
+          </a:xfrm>
+          <a:prstGeom prst="bentConnector5">
+            <a:avLst>
+              <a:gd name="adj1" fmla="val -33573"/>
+              <a:gd name="adj2" fmla="val 45473"/>
+              <a:gd name="adj3" fmla="val 253878"/>
+            </a:avLst>
+          </a:prstGeom>
+          <a:ln w="38100">
+            <a:tailEnd type="triangle"/>
+          </a:ln>
+        </p:spPr>
+        <p:style>
+          <a:lnRef idx="2">
+            <a:schemeClr val="dk1"/>
+          </a:lnRef>
+          <a:fillRef idx="0">
+            <a:schemeClr val="dk1"/>
+          </a:fillRef>
+          <a:effectRef idx="1">
+            <a:schemeClr val="dk1"/>
+          </a:effectRef>
+          <a:fontRef idx="minor">
+            <a:schemeClr val="tx1"/>
+          </a:fontRef>
+        </p:style>
+      </p:cxnSp>
+      <p:cxnSp>
+        <p:nvCxnSpPr>
+          <p:cNvPr id="245" name="Elbow Connector 244">
+            <a:extLst>
+              <a:ext uri="{FF2B5EF4-FFF2-40B4-BE49-F238E27FC236}">
+                <a16:creationId xmlns:a16="http://schemas.microsoft.com/office/drawing/2014/main" id="{2BAB6FC4-08EF-3B2E-4E28-66AC35CA0206}"/>
+              </a:ext>
+            </a:extLst>
+          </p:cNvPr>
+          <p:cNvCxnSpPr>
+            <a:cxnSpLocks/>
+            <a:stCxn id="24" idx="3"/>
+            <a:endCxn id="230" idx="1"/>
+          </p:cNvCxnSpPr>
+          <p:nvPr/>
+        </p:nvCxnSpPr>
+        <p:spPr>
+          <a:xfrm flipH="1">
+            <a:off x="2211057" y="553392"/>
+            <a:ext cx="682564" cy="5419851"/>
+          </a:xfrm>
+          <a:prstGeom prst="bentConnector5">
+            <a:avLst>
+              <a:gd name="adj1" fmla="val -33491"/>
+              <a:gd name="adj2" fmla="val 48211"/>
+              <a:gd name="adj3" fmla="val 252571"/>
+            </a:avLst>
+          </a:prstGeom>
+          <a:ln w="38100">
+            <a:tailEnd type="triangle"/>
+          </a:ln>
+        </p:spPr>
+        <p:style>
+          <a:lnRef idx="2">
+            <a:schemeClr val="dk1"/>
+          </a:lnRef>
+          <a:fillRef idx="0">
+            <a:schemeClr val="dk1"/>
+          </a:fillRef>
+          <a:effectRef idx="1">
+            <a:schemeClr val="dk1"/>
+          </a:effectRef>
+          <a:fontRef idx="minor">
+            <a:schemeClr val="tx1"/>
+          </a:fontRef>
+        </p:style>
+      </p:cxnSp>
+      <p:sp>
+        <p:nvSpPr>
+          <p:cNvPr id="251" name="Rectangle 250">
+            <a:extLst>
+              <a:ext uri="{FF2B5EF4-FFF2-40B4-BE49-F238E27FC236}">
+                <a16:creationId xmlns:a16="http://schemas.microsoft.com/office/drawing/2014/main" id="{0DE18C41-7D69-C3A8-2E4C-550B0C257405}"/>
               </a:ext>
             </a:extLst>
           </p:cNvPr>
@@ -8385,8 +8317,8 @@
         </p:nvSpPr>
         <p:spPr>
           <a:xfrm>
-            <a:off x="4261475" y="6205437"/>
-            <a:ext cx="1652437" cy="242864"/>
+            <a:off x="4241656" y="5820809"/>
+            <a:ext cx="1002645" cy="235607"/>
           </a:xfrm>
           <a:prstGeom prst="rect">
             <a:avLst/>
@@ -8425,10 +8357,10 @@
       </p:sp>
       <p:pic>
         <p:nvPicPr>
-          <p:cNvPr id="255" name="Graphic 254" descr="Repeat with solid fill">
-            <a:extLst>
-              <a:ext uri="{FF2B5EF4-FFF2-40B4-BE49-F238E27FC236}">
-                <a16:creationId xmlns:a16="http://schemas.microsoft.com/office/drawing/2014/main" id="{38DDCA80-E0E1-7C0E-EB15-733B8914F936}"/>
+          <p:cNvPr id="252" name="Graphic 251" descr="Repeat with solid fill">
+            <a:extLst>
+              <a:ext uri="{FF2B5EF4-FFF2-40B4-BE49-F238E27FC236}">
+                <a16:creationId xmlns:a16="http://schemas.microsoft.com/office/drawing/2014/main" id="{67A996B4-F823-EC67-0AE1-4EE31A3646EC}"/>
               </a:ext>
             </a:extLst>
           </p:cNvPr>
@@ -8438,10 +8370,10 @@
           <p:nvPr/>
         </p:nvPicPr>
         <p:blipFill>
-          <a:blip r:embed="rId2">
+          <a:blip>
             <a:extLst>
               <a:ext uri="{96DAC541-7B7A-43D3-8B79-37D633B846F1}">
-                <asvg:svgBlip xmlns:asvg="http://schemas.microsoft.com/office/drawing/2016/SVG/main" r:embed="rId3"/>
+                <asvg:svgBlip xmlns:asvg="http://schemas.microsoft.com/office/drawing/2016/SVG/main" r:embed="rId2"/>
               </a:ext>
             </a:extLst>
           </a:blip>
@@ -8451,7 +8383,7 @@
         </p:blipFill>
         <p:spPr>
           <a:xfrm>
-            <a:off x="4123510" y="5991903"/>
+            <a:off x="4103691" y="5607275"/>
             <a:ext cx="366563" cy="366563"/>
           </a:xfrm>
           <a:prstGeom prst="rect">
@@ -8461,10 +8393,10 @@
       </p:pic>
       <p:sp>
         <p:nvSpPr>
-          <p:cNvPr id="256" name="TextBox 255">
-            <a:extLst>
-              <a:ext uri="{FF2B5EF4-FFF2-40B4-BE49-F238E27FC236}">
-                <a16:creationId xmlns:a16="http://schemas.microsoft.com/office/drawing/2014/main" id="{CB709F97-5D18-8E1F-EB03-274F995138A7}"/>
+          <p:cNvPr id="253" name="TextBox 252">
+            <a:extLst>
+              <a:ext uri="{FF2B5EF4-FFF2-40B4-BE49-F238E27FC236}">
+                <a16:creationId xmlns:a16="http://schemas.microsoft.com/office/drawing/2014/main" id="{7CDEFB63-7160-738C-F4FD-61210C50AEF9}"/>
               </a:ext>
             </a:extLst>
           </p:cNvPr>
@@ -8473,8 +8405,8 @@
         </p:nvSpPr>
         <p:spPr>
           <a:xfrm>
-            <a:off x="4202156" y="6195494"/>
-            <a:ext cx="1745286" cy="276999"/>
+            <a:off x="4179018" y="5810866"/>
+            <a:ext cx="1011302" cy="276999"/>
           </a:xfrm>
           <a:prstGeom prst="rect">
             <a:avLst/>
@@ -8489,196 +8421,17 @@
           <a:p>
             <a:r>
               <a:rPr lang="en-US" sz="1200" noProof="1"/>
-              <a:t>create-overview-kml.sh</a:t>
-            </a:r>
-          </a:p>
-        </p:txBody>
-      </p:sp>
-      <p:cxnSp>
-        <p:nvCxnSpPr>
-          <p:cNvPr id="257" name="Elbow Connector 256">
-            <a:extLst>
-              <a:ext uri="{FF2B5EF4-FFF2-40B4-BE49-F238E27FC236}">
-                <a16:creationId xmlns:a16="http://schemas.microsoft.com/office/drawing/2014/main" id="{1AE0C03A-E3D0-6F9B-8F09-C0B4EE6E3133}"/>
-              </a:ext>
-            </a:extLst>
-          </p:cNvPr>
-          <p:cNvCxnSpPr>
-            <a:cxnSpLocks/>
-            <a:stCxn id="230" idx="3"/>
-          </p:cNvCxnSpPr>
-          <p:nvPr/>
-        </p:nvCxnSpPr>
-        <p:spPr>
-          <a:xfrm flipV="1">
-            <a:off x="3835730" y="5964661"/>
-            <a:ext cx="387013" cy="8582"/>
-          </a:xfrm>
-          <a:prstGeom prst="bentConnector3">
-            <a:avLst>
-              <a:gd name="adj1" fmla="val 50000"/>
-            </a:avLst>
-          </a:prstGeom>
-          <a:ln w="38100">
-            <a:tailEnd type="triangle"/>
-          </a:ln>
-        </p:spPr>
-        <p:style>
-          <a:lnRef idx="2">
-            <a:schemeClr val="dk1"/>
-          </a:lnRef>
-          <a:fillRef idx="0">
-            <a:schemeClr val="dk1"/>
-          </a:fillRef>
-          <a:effectRef idx="1">
-            <a:schemeClr val="dk1"/>
-          </a:effectRef>
-          <a:fontRef idx="minor">
-            <a:schemeClr val="tx1"/>
-          </a:fontRef>
-        </p:style>
-      </p:cxnSp>
-      <p:cxnSp>
-        <p:nvCxnSpPr>
-          <p:cNvPr id="262" name="Elbow Connector 261">
-            <a:extLst>
-              <a:ext uri="{FF2B5EF4-FFF2-40B4-BE49-F238E27FC236}">
-                <a16:creationId xmlns:a16="http://schemas.microsoft.com/office/drawing/2014/main" id="{E7DDF635-308E-C78A-FAEC-8636C3FF0A9B}"/>
-              </a:ext>
-            </a:extLst>
-          </p:cNvPr>
-          <p:cNvCxnSpPr>
-            <a:cxnSpLocks/>
-            <a:stCxn id="4" idx="2"/>
-            <a:endCxn id="256" idx="1"/>
-          </p:cNvCxnSpPr>
-          <p:nvPr/>
-        </p:nvCxnSpPr>
-        <p:spPr>
-          <a:xfrm rot="16200000" flipH="1">
-            <a:off x="2414112" y="4545950"/>
-            <a:ext cx="3087254" cy="488833"/>
-          </a:xfrm>
-          <a:prstGeom prst="bentConnector2">
-            <a:avLst/>
-          </a:prstGeom>
-          <a:ln w="38100">
-            <a:tailEnd type="triangle"/>
-          </a:ln>
-        </p:spPr>
-        <p:style>
-          <a:lnRef idx="2">
-            <a:schemeClr val="dk1"/>
-          </a:lnRef>
-          <a:fillRef idx="0">
-            <a:schemeClr val="dk1"/>
-          </a:fillRef>
-          <a:effectRef idx="1">
-            <a:schemeClr val="dk1"/>
-          </a:effectRef>
-          <a:fontRef idx="minor">
-            <a:schemeClr val="tx1"/>
-          </a:fontRef>
-        </p:style>
-      </p:cxnSp>
-      <p:cxnSp>
-        <p:nvCxnSpPr>
-          <p:cNvPr id="265" name="Elbow Connector 264">
-            <a:extLst>
-              <a:ext uri="{FF2B5EF4-FFF2-40B4-BE49-F238E27FC236}">
-                <a16:creationId xmlns:a16="http://schemas.microsoft.com/office/drawing/2014/main" id="{03AF12DC-32B0-6A0E-BAD3-2B75F19ADEEB}"/>
-              </a:ext>
-            </a:extLst>
-          </p:cNvPr>
-          <p:cNvCxnSpPr>
-            <a:cxnSpLocks/>
-            <a:stCxn id="4" idx="2"/>
-            <a:endCxn id="230" idx="1"/>
-          </p:cNvCxnSpPr>
-          <p:nvPr/>
-        </p:nvCxnSpPr>
-        <p:spPr>
-          <a:xfrm rot="5400000">
-            <a:off x="1598939" y="3858858"/>
-            <a:ext cx="2726503" cy="1502266"/>
-          </a:xfrm>
-          <a:prstGeom prst="bentConnector4">
-            <a:avLst>
-              <a:gd name="adj1" fmla="val 56098"/>
-              <a:gd name="adj2" fmla="val 115217"/>
-            </a:avLst>
-          </a:prstGeom>
-          <a:ln w="38100">
-            <a:tailEnd type="triangle"/>
-          </a:ln>
-        </p:spPr>
-        <p:style>
-          <a:lnRef idx="2">
-            <a:schemeClr val="dk1"/>
-          </a:lnRef>
-          <a:fillRef idx="0">
-            <a:schemeClr val="dk1"/>
-          </a:fillRef>
-          <a:effectRef idx="1">
-            <a:schemeClr val="dk1"/>
-          </a:effectRef>
-          <a:fontRef idx="minor">
-            <a:schemeClr val="tx1"/>
-          </a:fontRef>
-        </p:style>
-      </p:cxnSp>
-      <p:cxnSp>
-        <p:nvCxnSpPr>
-          <p:cNvPr id="278" name="Elbow Connector 277">
-            <a:extLst>
-              <a:ext uri="{FF2B5EF4-FFF2-40B4-BE49-F238E27FC236}">
-                <a16:creationId xmlns:a16="http://schemas.microsoft.com/office/drawing/2014/main" id="{60EE083B-F0F2-219E-FD1C-938D14EBE610}"/>
-              </a:ext>
-            </a:extLst>
-          </p:cNvPr>
-          <p:cNvCxnSpPr>
-            <a:cxnSpLocks/>
-            <a:stCxn id="8" idx="0"/>
-            <a:endCxn id="235" idx="1"/>
-          </p:cNvCxnSpPr>
-          <p:nvPr/>
-        </p:nvCxnSpPr>
-        <p:spPr>
-          <a:xfrm rot="16200000" flipH="1">
-            <a:off x="-554281" y="3913792"/>
-            <a:ext cx="4799551" cy="701287"/>
-          </a:xfrm>
-          <a:prstGeom prst="bentConnector4">
-            <a:avLst>
-              <a:gd name="adj1" fmla="val -2536"/>
-              <a:gd name="adj2" fmla="val -232168"/>
-            </a:avLst>
-          </a:prstGeom>
-          <a:ln w="38100">
-            <a:tailEnd type="triangle"/>
-          </a:ln>
-        </p:spPr>
-        <p:style>
-          <a:lnRef idx="2">
-            <a:schemeClr val="dk1"/>
-          </a:lnRef>
-          <a:fillRef idx="0">
-            <a:schemeClr val="dk1"/>
-          </a:fillRef>
-          <a:effectRef idx="1">
-            <a:schemeClr val="dk1"/>
-          </a:effectRef>
-          <a:fontRef idx="minor">
-            <a:schemeClr val="tx1"/>
-          </a:fontRef>
-        </p:style>
-      </p:cxnSp>
-      <p:sp>
-        <p:nvSpPr>
-          <p:cNvPr id="289" name="Rectangle 288">
-            <a:extLst>
-              <a:ext uri="{FF2B5EF4-FFF2-40B4-BE49-F238E27FC236}">
-                <a16:creationId xmlns:a16="http://schemas.microsoft.com/office/drawing/2014/main" id="{0CAA2824-AD66-7A27-E452-E3299C00B2E5}"/>
+              <a:t>email-log.sh</a:t>
+            </a:r>
+          </a:p>
+        </p:txBody>
+      </p:sp>
+      <p:sp>
+        <p:nvSpPr>
+          <p:cNvPr id="254" name="Rectangle 253">
+            <a:extLst>
+              <a:ext uri="{FF2B5EF4-FFF2-40B4-BE49-F238E27FC236}">
+                <a16:creationId xmlns:a16="http://schemas.microsoft.com/office/drawing/2014/main" id="{1F4EA00B-6D53-7E05-F41D-830F9BDC1505}"/>
               </a:ext>
             </a:extLst>
           </p:cNvPr>
@@ -8687,14 +8440,17 @@
         </p:nvSpPr>
         <p:spPr>
           <a:xfrm>
-            <a:off x="6518976" y="5521900"/>
-            <a:ext cx="1342489" cy="674380"/>
+            <a:off x="4261475" y="6205437"/>
+            <a:ext cx="1652437" cy="242864"/>
           </a:xfrm>
           <a:prstGeom prst="rect">
             <a:avLst/>
           </a:prstGeom>
           <a:solidFill>
-            <a:srgbClr val="FFC000"/>
+            <a:schemeClr val="accent2">
+              <a:lumMod val="60000"/>
+              <a:lumOff val="40000"/>
+            </a:schemeClr>
           </a:solidFill>
         </p:spPr>
         <p:style>
@@ -8722,12 +8478,48 @@
           </a:p>
         </p:txBody>
       </p:sp>
-      <p:sp>
-        <p:nvSpPr>
-          <p:cNvPr id="290" name="TextBox 289">
-            <a:extLst>
-              <a:ext uri="{FF2B5EF4-FFF2-40B4-BE49-F238E27FC236}">
-                <a16:creationId xmlns:a16="http://schemas.microsoft.com/office/drawing/2014/main" id="{29625248-F791-B6AA-F224-3FC10DF36286}"/>
+      <p:pic>
+        <p:nvPicPr>
+          <p:cNvPr id="255" name="Graphic 254" descr="Repeat with solid fill">
+            <a:extLst>
+              <a:ext uri="{FF2B5EF4-FFF2-40B4-BE49-F238E27FC236}">
+                <a16:creationId xmlns:a16="http://schemas.microsoft.com/office/drawing/2014/main" id="{38DDCA80-E0E1-7C0E-EB15-733B8914F936}"/>
+              </a:ext>
+            </a:extLst>
+          </p:cNvPr>
+          <p:cNvPicPr>
+            <a:picLocks noChangeAspect="1"/>
+          </p:cNvPicPr>
+          <p:nvPr/>
+        </p:nvPicPr>
+        <p:blipFill>
+          <a:blip>
+            <a:extLst>
+              <a:ext uri="{96DAC541-7B7A-43D3-8B79-37D633B846F1}">
+                <asvg:svgBlip xmlns:asvg="http://schemas.microsoft.com/office/drawing/2016/SVG/main" r:embed="rId2"/>
+              </a:ext>
+            </a:extLst>
+          </a:blip>
+          <a:stretch>
+            <a:fillRect/>
+          </a:stretch>
+        </p:blipFill>
+        <p:spPr>
+          <a:xfrm>
+            <a:off x="4123510" y="5991903"/>
+            <a:ext cx="366563" cy="366563"/>
+          </a:xfrm>
+          <a:prstGeom prst="rect">
+            <a:avLst/>
+          </a:prstGeom>
+        </p:spPr>
+      </p:pic>
+      <p:sp>
+        <p:nvSpPr>
+          <p:cNvPr id="256" name="TextBox 255">
+            <a:extLst>
+              <a:ext uri="{FF2B5EF4-FFF2-40B4-BE49-F238E27FC236}">
+                <a16:creationId xmlns:a16="http://schemas.microsoft.com/office/drawing/2014/main" id="{CB709F97-5D18-8E1F-EB03-274F995138A7}"/>
               </a:ext>
             </a:extLst>
           </p:cNvPr>
@@ -8736,8 +8528,8 @@
         </p:nvSpPr>
         <p:spPr>
           <a:xfrm>
-            <a:off x="6502981" y="5580220"/>
-            <a:ext cx="1008609" cy="276999"/>
+            <a:off x="4202156" y="6195494"/>
+            <a:ext cx="1745286" cy="276999"/>
           </a:xfrm>
           <a:prstGeom prst="rect">
             <a:avLst/>
@@ -8752,41 +8544,38 @@
           <a:p>
             <a:r>
               <a:rPr lang="en-US" sz="1200" noProof="1"/>
-              <a:t>Risk module</a:t>
+              <a:t>create-overview-kml.sh</a:t>
             </a:r>
           </a:p>
         </p:txBody>
       </p:sp>
       <p:cxnSp>
         <p:nvCxnSpPr>
-          <p:cNvPr id="298" name="Elbow Connector 297">
-            <a:extLst>
-              <a:ext uri="{FF2B5EF4-FFF2-40B4-BE49-F238E27FC236}">
-                <a16:creationId xmlns:a16="http://schemas.microsoft.com/office/drawing/2014/main" id="{3CD32CFC-B131-B4C0-37F1-F50938DF9027}"/>
+          <p:cNvPr id="257" name="Elbow Connector 256">
+            <a:extLst>
+              <a:ext uri="{FF2B5EF4-FFF2-40B4-BE49-F238E27FC236}">
+                <a16:creationId xmlns:a16="http://schemas.microsoft.com/office/drawing/2014/main" id="{1AE0C03A-E3D0-6F9B-8F09-C0B4EE6E3133}"/>
               </a:ext>
             </a:extLst>
           </p:cNvPr>
           <p:cNvCxnSpPr>
             <a:cxnSpLocks/>
-            <a:stCxn id="105" idx="2"/>
-            <a:endCxn id="203" idx="0"/>
+            <a:stCxn id="230" idx="3"/>
           </p:cNvCxnSpPr>
           <p:nvPr/>
         </p:nvCxnSpPr>
         <p:spPr>
-          <a:xfrm rot="5400000">
-            <a:off x="6338678" y="1605697"/>
-            <a:ext cx="2521219" cy="996120"/>
+          <a:xfrm flipV="1">
+            <a:off x="3835730" y="5964661"/>
+            <a:ext cx="387013" cy="8582"/>
           </a:xfrm>
           <a:prstGeom prst="bentConnector3">
             <a:avLst>
-              <a:gd name="adj1" fmla="val 11848"/>
+              <a:gd name="adj1" fmla="val 50000"/>
             </a:avLst>
           </a:prstGeom>
           <a:ln w="38100">
-            <a:prstDash val="dash"/>
-            <a:headEnd type="triangle" w="med" len="med"/>
-            <a:tailEnd type="triangle" w="med" len="med"/>
+            <a:tailEnd type="triangle"/>
           </a:ln>
         </p:spPr>
         <p:style>
@@ -8806,32 +8595,30 @@
       </p:cxnSp>
       <p:cxnSp>
         <p:nvCxnSpPr>
-          <p:cNvPr id="306" name="Elbow Connector 305">
-            <a:extLst>
-              <a:ext uri="{FF2B5EF4-FFF2-40B4-BE49-F238E27FC236}">
-                <a16:creationId xmlns:a16="http://schemas.microsoft.com/office/drawing/2014/main" id="{A2BD6CC8-010E-C75F-9045-58E249025B12}"/>
+          <p:cNvPr id="262" name="Elbow Connector 261">
+            <a:extLst>
+              <a:ext uri="{FF2B5EF4-FFF2-40B4-BE49-F238E27FC236}">
+                <a16:creationId xmlns:a16="http://schemas.microsoft.com/office/drawing/2014/main" id="{E7DDF635-308E-C78A-FAEC-8636C3FF0A9B}"/>
               </a:ext>
             </a:extLst>
           </p:cNvPr>
           <p:cNvCxnSpPr>
             <a:cxnSpLocks/>
-            <a:stCxn id="124" idx="1"/>
-            <a:endCxn id="203" idx="0"/>
+            <a:stCxn id="4" idx="2"/>
+            <a:endCxn id="256" idx="1"/>
           </p:cNvCxnSpPr>
           <p:nvPr/>
         </p:nvCxnSpPr>
         <p:spPr>
-          <a:xfrm rot="10800000" flipV="1">
-            <a:off x="7101228" y="2096827"/>
-            <a:ext cx="133597" cy="1267539"/>
+          <a:xfrm rot="16200000" flipH="1">
+            <a:off x="2414112" y="4545950"/>
+            <a:ext cx="3087254" cy="488833"/>
           </a:xfrm>
           <a:prstGeom prst="bentConnector2">
             <a:avLst/>
           </a:prstGeom>
           <a:ln w="38100">
-            <a:prstDash val="dash"/>
-            <a:headEnd type="triangle" w="med" len="med"/>
-            <a:tailEnd type="triangle" w="med" len="med"/>
+            <a:tailEnd type="triangle"/>
           </a:ln>
         </p:spPr>
         <p:style>
@@ -8851,33 +8638,33 @@
       </p:cxnSp>
       <p:cxnSp>
         <p:nvCxnSpPr>
-          <p:cNvPr id="318" name="Elbow Connector 317">
-            <a:extLst>
-              <a:ext uri="{FF2B5EF4-FFF2-40B4-BE49-F238E27FC236}">
-                <a16:creationId xmlns:a16="http://schemas.microsoft.com/office/drawing/2014/main" id="{F16A25D0-3C85-6841-BBF3-CF40983677B6}"/>
+          <p:cNvPr id="265" name="Elbow Connector 264">
+            <a:extLst>
+              <a:ext uri="{FF2B5EF4-FFF2-40B4-BE49-F238E27FC236}">
+                <a16:creationId xmlns:a16="http://schemas.microsoft.com/office/drawing/2014/main" id="{03AF12DC-32B0-6A0E-BAD3-2B75F19ADEEB}"/>
               </a:ext>
             </a:extLst>
           </p:cNvPr>
           <p:cNvCxnSpPr>
             <a:cxnSpLocks/>
-            <a:stCxn id="204" idx="3"/>
+            <a:stCxn id="4" idx="2"/>
+            <a:endCxn id="230" idx="1"/>
           </p:cNvCxnSpPr>
           <p:nvPr/>
         </p:nvCxnSpPr>
         <p:spPr>
-          <a:xfrm flipV="1">
-            <a:off x="3293181" y="3713482"/>
-            <a:ext cx="2726105" cy="364626"/>
-          </a:xfrm>
-          <a:prstGeom prst="bentConnector3">
+          <a:xfrm rot="5400000">
+            <a:off x="1598939" y="3858858"/>
+            <a:ext cx="2726503" cy="1502266"/>
+          </a:xfrm>
+          <a:prstGeom prst="bentConnector4">
             <a:avLst>
-              <a:gd name="adj1" fmla="val 50000"/>
+              <a:gd name="adj1" fmla="val 56098"/>
+              <a:gd name="adj2" fmla="val 115217"/>
             </a:avLst>
           </a:prstGeom>
           <a:ln w="38100">
-            <a:prstDash val="dash"/>
-            <a:headEnd type="none" w="med" len="med"/>
-            <a:tailEnd type="triangle" w="med" len="med"/>
+            <a:tailEnd type="triangle"/>
           </a:ln>
         </p:spPr>
         <p:style>
@@ -8897,35 +8684,33 @@
       </p:cxnSp>
       <p:cxnSp>
         <p:nvCxnSpPr>
-          <p:cNvPr id="323" name="Elbow Connector 322">
-            <a:extLst>
-              <a:ext uri="{FF2B5EF4-FFF2-40B4-BE49-F238E27FC236}">
-                <a16:creationId xmlns:a16="http://schemas.microsoft.com/office/drawing/2014/main" id="{290FC449-2309-C9B3-D4D9-AD89940C3FDF}"/>
+          <p:cNvPr id="278" name="Elbow Connector 277">
+            <a:extLst>
+              <a:ext uri="{FF2B5EF4-FFF2-40B4-BE49-F238E27FC236}">
+                <a16:creationId xmlns:a16="http://schemas.microsoft.com/office/drawing/2014/main" id="{60EE083B-F0F2-219E-FD1C-938D14EBE610}"/>
               </a:ext>
             </a:extLst>
           </p:cNvPr>
           <p:cNvCxnSpPr>
             <a:cxnSpLocks/>
-            <a:stCxn id="124" idx="3"/>
-            <a:endCxn id="289" idx="0"/>
+            <a:stCxn id="8" idx="0"/>
+            <a:endCxn id="235" idx="1"/>
           </p:cNvCxnSpPr>
           <p:nvPr/>
         </p:nvCxnSpPr>
         <p:spPr>
-          <a:xfrm flipH="1">
-            <a:off x="7190221" y="2096828"/>
-            <a:ext cx="2255307" cy="3425072"/>
+          <a:xfrm rot="16200000" flipH="1">
+            <a:off x="-725810" y="4085321"/>
+            <a:ext cx="5142971" cy="701648"/>
           </a:xfrm>
           <a:prstGeom prst="bentConnector4">
             <a:avLst>
-              <a:gd name="adj1" fmla="val -7503"/>
-              <a:gd name="adj2" fmla="val 66294"/>
+              <a:gd name="adj1" fmla="val -2716"/>
+              <a:gd name="adj2" fmla="val -234920"/>
             </a:avLst>
           </a:prstGeom>
           <a:ln w="38100">
-            <a:prstDash val="dash"/>
-            <a:headEnd type="triangle" w="med" len="med"/>
-            <a:tailEnd type="triangle" w="med" len="med"/>
+            <a:tailEnd type="triangle"/>
           </a:ln>
         </p:spPr>
         <p:style>
@@ -8943,291 +8728,12 @@
           </a:fontRef>
         </p:style>
       </p:cxnSp>
-      <p:cxnSp>
-        <p:nvCxnSpPr>
-          <p:cNvPr id="330" name="Elbow Connector 329">
-            <a:extLst>
-              <a:ext uri="{FF2B5EF4-FFF2-40B4-BE49-F238E27FC236}">
-                <a16:creationId xmlns:a16="http://schemas.microsoft.com/office/drawing/2014/main" id="{D145EBC3-6A0E-CB95-C9FF-C8370282382E}"/>
-              </a:ext>
-            </a:extLst>
-          </p:cNvPr>
-          <p:cNvCxnSpPr>
-            <a:cxnSpLocks/>
-            <a:stCxn id="202" idx="2"/>
-            <a:endCxn id="289" idx="0"/>
-          </p:cNvCxnSpPr>
-          <p:nvPr/>
-        </p:nvCxnSpPr>
-        <p:spPr>
-          <a:xfrm rot="16200000" flipH="1">
-            <a:off x="6432051" y="4763730"/>
-            <a:ext cx="1471370" cy="44970"/>
-          </a:xfrm>
-          <a:prstGeom prst="bentConnector3">
-            <a:avLst>
-              <a:gd name="adj1" fmla="val 50000"/>
-            </a:avLst>
-          </a:prstGeom>
-          <a:ln w="38100">
-            <a:prstDash val="dash"/>
-            <a:headEnd type="triangle" w="med" len="med"/>
-            <a:tailEnd type="triangle" w="med" len="med"/>
-          </a:ln>
-        </p:spPr>
-        <p:style>
-          <a:lnRef idx="2">
-            <a:schemeClr val="dk1"/>
-          </a:lnRef>
-          <a:fillRef idx="0">
-            <a:schemeClr val="dk1"/>
-          </a:fillRef>
-          <a:effectRef idx="1">
-            <a:schemeClr val="dk1"/>
-          </a:effectRef>
-          <a:fontRef idx="minor">
-            <a:schemeClr val="tx1"/>
-          </a:fontRef>
-        </p:style>
-      </p:cxnSp>
-      <p:cxnSp>
-        <p:nvCxnSpPr>
-          <p:cNvPr id="334" name="Elbow Connector 333">
-            <a:extLst>
-              <a:ext uri="{FF2B5EF4-FFF2-40B4-BE49-F238E27FC236}">
-                <a16:creationId xmlns:a16="http://schemas.microsoft.com/office/drawing/2014/main" id="{760BFCB2-3D62-F50C-E73E-78B7EE7581DB}"/>
-              </a:ext>
-            </a:extLst>
-          </p:cNvPr>
-          <p:cNvCxnSpPr>
-            <a:cxnSpLocks/>
-            <a:stCxn id="204" idx="3"/>
-            <a:endCxn id="289" idx="1"/>
-          </p:cNvCxnSpPr>
-          <p:nvPr/>
-        </p:nvCxnSpPr>
-        <p:spPr>
-          <a:xfrm>
-            <a:off x="3293181" y="4078108"/>
-            <a:ext cx="3225795" cy="1780982"/>
-          </a:xfrm>
-          <a:prstGeom prst="bentConnector3">
-            <a:avLst>
-              <a:gd name="adj1" fmla="val 73140"/>
-            </a:avLst>
-          </a:prstGeom>
-          <a:ln w="38100">
-            <a:prstDash val="dash"/>
-            <a:headEnd type="none" w="med" len="med"/>
-            <a:tailEnd type="triangle" w="med" len="med"/>
-          </a:ln>
-        </p:spPr>
-        <p:style>
-          <a:lnRef idx="2">
-            <a:schemeClr val="dk1"/>
-          </a:lnRef>
-          <a:fillRef idx="0">
-            <a:schemeClr val="dk1"/>
-          </a:fillRef>
-          <a:effectRef idx="1">
-            <a:schemeClr val="dk1"/>
-          </a:effectRef>
-          <a:fontRef idx="minor">
-            <a:schemeClr val="tx1"/>
-          </a:fontRef>
-        </p:style>
-      </p:cxnSp>
-      <p:cxnSp>
-        <p:nvCxnSpPr>
-          <p:cNvPr id="341" name="Elbow Connector 340">
-            <a:extLst>
-              <a:ext uri="{FF2B5EF4-FFF2-40B4-BE49-F238E27FC236}">
-                <a16:creationId xmlns:a16="http://schemas.microsoft.com/office/drawing/2014/main" id="{24005D6A-4DC3-B548-8E21-828250BBEDDB}"/>
-              </a:ext>
-            </a:extLst>
-          </p:cNvPr>
-          <p:cNvCxnSpPr>
-            <a:cxnSpLocks/>
-            <a:stCxn id="289" idx="3"/>
-            <a:endCxn id="167" idx="1"/>
-          </p:cNvCxnSpPr>
-          <p:nvPr/>
-        </p:nvCxnSpPr>
-        <p:spPr>
-          <a:xfrm flipV="1">
-            <a:off x="7861465" y="5542150"/>
-            <a:ext cx="1975283" cy="316940"/>
-          </a:xfrm>
-          <a:prstGeom prst="bentConnector3">
-            <a:avLst>
-              <a:gd name="adj1" fmla="val 50000"/>
-            </a:avLst>
-          </a:prstGeom>
-          <a:ln w="38100">
-            <a:prstDash val="dash"/>
-            <a:headEnd type="none" w="med" len="med"/>
-            <a:tailEnd type="triangle" w="med" len="med"/>
-          </a:ln>
-        </p:spPr>
-        <p:style>
-          <a:lnRef idx="2">
-            <a:schemeClr val="dk1"/>
-          </a:lnRef>
-          <a:fillRef idx="0">
-            <a:schemeClr val="dk1"/>
-          </a:fillRef>
-          <a:effectRef idx="1">
-            <a:schemeClr val="dk1"/>
-          </a:effectRef>
-          <a:fontRef idx="minor">
-            <a:schemeClr val="tx1"/>
-          </a:fontRef>
-        </p:style>
-      </p:cxnSp>
-      <p:cxnSp>
-        <p:nvCxnSpPr>
-          <p:cNvPr id="344" name="Elbow Connector 343">
-            <a:extLst>
-              <a:ext uri="{FF2B5EF4-FFF2-40B4-BE49-F238E27FC236}">
-                <a16:creationId xmlns:a16="http://schemas.microsoft.com/office/drawing/2014/main" id="{2784287A-736E-68DE-209D-219212CEB8E3}"/>
-              </a:ext>
-            </a:extLst>
-          </p:cNvPr>
-          <p:cNvCxnSpPr>
-            <a:cxnSpLocks/>
-            <a:stCxn id="289" idx="3"/>
-            <a:endCxn id="228" idx="3"/>
-          </p:cNvCxnSpPr>
-          <p:nvPr/>
-        </p:nvCxnSpPr>
-        <p:spPr>
-          <a:xfrm flipH="1">
-            <a:off x="6019288" y="5859090"/>
-            <a:ext cx="1842177" cy="502003"/>
-          </a:xfrm>
-          <a:prstGeom prst="bentConnector3">
-            <a:avLst>
-              <a:gd name="adj1" fmla="val -12409"/>
-            </a:avLst>
-          </a:prstGeom>
-          <a:ln w="38100">
-            <a:prstDash val="dash"/>
-            <a:headEnd type="none" w="med" len="med"/>
-            <a:tailEnd type="triangle" w="med" len="med"/>
-          </a:ln>
-        </p:spPr>
-        <p:style>
-          <a:lnRef idx="2">
-            <a:schemeClr val="dk1"/>
-          </a:lnRef>
-          <a:fillRef idx="0">
-            <a:schemeClr val="dk1"/>
-          </a:fillRef>
-          <a:effectRef idx="1">
-            <a:schemeClr val="dk1"/>
-          </a:effectRef>
-          <a:fontRef idx="minor">
-            <a:schemeClr val="tx1"/>
-          </a:fontRef>
-        </p:style>
-      </p:cxnSp>
-      <p:cxnSp>
-        <p:nvCxnSpPr>
-          <p:cNvPr id="356" name="Elbow Connector 355">
-            <a:extLst>
-              <a:ext uri="{FF2B5EF4-FFF2-40B4-BE49-F238E27FC236}">
-                <a16:creationId xmlns:a16="http://schemas.microsoft.com/office/drawing/2014/main" id="{A0F63EF9-019B-28D7-1FF7-EABE30B73796}"/>
-              </a:ext>
-            </a:extLst>
-          </p:cNvPr>
-          <p:cNvCxnSpPr>
-            <a:cxnSpLocks/>
-            <a:stCxn id="151" idx="3"/>
-            <a:endCxn id="190" idx="3"/>
-          </p:cNvCxnSpPr>
-          <p:nvPr/>
-        </p:nvCxnSpPr>
-        <p:spPr>
-          <a:xfrm>
-            <a:off x="11412875" y="3314444"/>
-            <a:ext cx="57357" cy="3013978"/>
-          </a:xfrm>
-          <a:prstGeom prst="bentConnector3">
-            <a:avLst>
-              <a:gd name="adj1" fmla="val 498556"/>
-            </a:avLst>
-          </a:prstGeom>
-          <a:ln w="38100">
-            <a:tailEnd type="triangle"/>
-          </a:ln>
-        </p:spPr>
-        <p:style>
-          <a:lnRef idx="2">
-            <a:schemeClr val="dk1"/>
-          </a:lnRef>
-          <a:fillRef idx="0">
-            <a:schemeClr val="dk1"/>
-          </a:fillRef>
-          <a:effectRef idx="1">
-            <a:schemeClr val="dk1"/>
-          </a:effectRef>
-          <a:fontRef idx="minor">
-            <a:schemeClr val="tx1"/>
-          </a:fontRef>
-        </p:style>
-      </p:cxnSp>
-      <p:cxnSp>
-        <p:nvCxnSpPr>
-          <p:cNvPr id="361" name="Elbow Connector 360">
-            <a:extLst>
-              <a:ext uri="{FF2B5EF4-FFF2-40B4-BE49-F238E27FC236}">
-                <a16:creationId xmlns:a16="http://schemas.microsoft.com/office/drawing/2014/main" id="{F9AC13C7-350C-1DC2-5BDE-3F9AD781F1FD}"/>
-              </a:ext>
-            </a:extLst>
-          </p:cNvPr>
-          <p:cNvCxnSpPr>
-            <a:cxnSpLocks/>
-            <a:stCxn id="232" idx="2"/>
-            <a:endCxn id="172" idx="1"/>
-          </p:cNvCxnSpPr>
-          <p:nvPr/>
-        </p:nvCxnSpPr>
-        <p:spPr>
-          <a:xfrm rot="5400000" flipH="1" flipV="1">
-            <a:off x="6041092" y="2137041"/>
-            <a:ext cx="1287043" cy="7325090"/>
-          </a:xfrm>
-          <a:prstGeom prst="bentConnector4">
-            <a:avLst>
-              <a:gd name="adj1" fmla="val -4578"/>
-              <a:gd name="adj2" fmla="val 76531"/>
-            </a:avLst>
-          </a:prstGeom>
-          <a:ln w="38100">
-            <a:tailEnd type="triangle"/>
-          </a:ln>
-        </p:spPr>
-        <p:style>
-          <a:lnRef idx="2">
-            <a:schemeClr val="dk1"/>
-          </a:lnRef>
-          <a:fillRef idx="0">
-            <a:schemeClr val="dk1"/>
-          </a:fillRef>
-          <a:effectRef idx="1">
-            <a:schemeClr val="dk1"/>
-          </a:effectRef>
-          <a:fontRef idx="minor">
-            <a:schemeClr val="tx1"/>
-          </a:fontRef>
-        </p:style>
-      </p:cxnSp>
-      <p:sp>
-        <p:nvSpPr>
-          <p:cNvPr id="411" name="Rectangle 410">
-            <a:extLst>
-              <a:ext uri="{FF2B5EF4-FFF2-40B4-BE49-F238E27FC236}">
-                <a16:creationId xmlns:a16="http://schemas.microsoft.com/office/drawing/2014/main" id="{73015C36-0E66-77F0-222A-AF2B22DB0131}"/>
+      <p:sp>
+        <p:nvSpPr>
+          <p:cNvPr id="289" name="Rectangle 288">
+            <a:extLst>
+              <a:ext uri="{FF2B5EF4-FFF2-40B4-BE49-F238E27FC236}">
+                <a16:creationId xmlns:a16="http://schemas.microsoft.com/office/drawing/2014/main" id="{0CAA2824-AD66-7A27-E452-E3299C00B2E5}"/>
               </a:ext>
             </a:extLst>
           </p:cNvPr>
@@ -9236,16 +8742,14 @@
         </p:nvSpPr>
         <p:spPr>
           <a:xfrm>
-            <a:off x="1416618" y="4260526"/>
-            <a:ext cx="1798521" cy="276999"/>
+            <a:off x="6518976" y="5521900"/>
+            <a:ext cx="1342489" cy="674380"/>
           </a:xfrm>
           <a:prstGeom prst="rect">
             <a:avLst/>
           </a:prstGeom>
           <a:solidFill>
-            <a:schemeClr val="bg2">
-              <a:lumMod val="90000"/>
-            </a:schemeClr>
+            <a:srgbClr val="FFC000"/>
           </a:solidFill>
         </p:spPr>
         <p:style>
@@ -9275,10 +8779,10 @@
       </p:sp>
       <p:sp>
         <p:nvSpPr>
-          <p:cNvPr id="412" name="TextBox 411">
-            <a:extLst>
-              <a:ext uri="{FF2B5EF4-FFF2-40B4-BE49-F238E27FC236}">
-                <a16:creationId xmlns:a16="http://schemas.microsoft.com/office/drawing/2014/main" id="{4B057196-5C1F-6BBE-C721-6AE09DC38A8F}"/>
+          <p:cNvPr id="290" name="TextBox 289">
+            <a:extLst>
+              <a:ext uri="{FF2B5EF4-FFF2-40B4-BE49-F238E27FC236}">
+                <a16:creationId xmlns:a16="http://schemas.microsoft.com/office/drawing/2014/main" id="{29625248-F791-B6AA-F224-3FC10DF36286}"/>
               </a:ext>
             </a:extLst>
           </p:cNvPr>
@@ -9287,8 +8791,8 @@
         </p:nvSpPr>
         <p:spPr>
           <a:xfrm>
-            <a:off x="1420935" y="4242051"/>
-            <a:ext cx="1721305" cy="276999"/>
+            <a:off x="6502981" y="5580220"/>
+            <a:ext cx="1008609" cy="276999"/>
           </a:xfrm>
           <a:prstGeom prst="rect">
             <a:avLst/>
@@ -9303,40 +8807,41 @@
           <a:p>
             <a:r>
               <a:rPr lang="en-US" sz="1200" noProof="1"/>
-              <a:t>parameter files (config)</a:t>
+              <a:t>Risk module</a:t>
             </a:r>
           </a:p>
         </p:txBody>
       </p:sp>
       <p:cxnSp>
         <p:nvCxnSpPr>
-          <p:cNvPr id="271" name="Elbow Connector 270">
-            <a:extLst>
-              <a:ext uri="{FF2B5EF4-FFF2-40B4-BE49-F238E27FC236}">
-                <a16:creationId xmlns:a16="http://schemas.microsoft.com/office/drawing/2014/main" id="{F1DCB39C-7841-7600-DE7A-8484CEBCFC65}"/>
+          <p:cNvPr id="298" name="Elbow Connector 297">
+            <a:extLst>
+              <a:ext uri="{FF2B5EF4-FFF2-40B4-BE49-F238E27FC236}">
+                <a16:creationId xmlns:a16="http://schemas.microsoft.com/office/drawing/2014/main" id="{3CD32CFC-B131-B4C0-37F1-F50938DF9027}"/>
               </a:ext>
             </a:extLst>
           </p:cNvPr>
           <p:cNvCxnSpPr>
             <a:cxnSpLocks/>
-            <a:stCxn id="10" idx="0"/>
-            <a:endCxn id="235" idx="1"/>
+            <a:stCxn id="105" idx="2"/>
+            <a:endCxn id="203" idx="0"/>
           </p:cNvCxnSpPr>
           <p:nvPr/>
         </p:nvCxnSpPr>
         <p:spPr>
-          <a:xfrm rot="16200000" flipH="1">
-            <a:off x="-107885" y="4360188"/>
-            <a:ext cx="4293048" cy="314999"/>
-          </a:xfrm>
-          <a:prstGeom prst="bentConnector4">
+          <a:xfrm rot="5400000">
+            <a:off x="6338678" y="1605697"/>
+            <a:ext cx="2521219" cy="996120"/>
+          </a:xfrm>
+          <a:prstGeom prst="bentConnector3">
             <a:avLst>
-              <a:gd name="adj1" fmla="val -4204"/>
-              <a:gd name="adj2" fmla="val -614790"/>
+              <a:gd name="adj1" fmla="val 11848"/>
             </a:avLst>
           </a:prstGeom>
           <a:ln w="38100">
-            <a:tailEnd type="triangle"/>
+            <a:prstDash val="dash"/>
+            <a:headEnd type="triangle" w="med" len="med"/>
+            <a:tailEnd type="triangle" w="med" len="med"/>
           </a:ln>
         </p:spPr>
         <p:style>
@@ -9356,34 +8861,32 @@
       </p:cxnSp>
       <p:cxnSp>
         <p:nvCxnSpPr>
-          <p:cNvPr id="413" name="Elbow Connector 412">
-            <a:extLst>
-              <a:ext uri="{FF2B5EF4-FFF2-40B4-BE49-F238E27FC236}">
-                <a16:creationId xmlns:a16="http://schemas.microsoft.com/office/drawing/2014/main" id="{A0C3B407-F4DE-374D-3AD3-97DFF9517D13}"/>
+          <p:cNvPr id="306" name="Elbow Connector 305">
+            <a:extLst>
+              <a:ext uri="{FF2B5EF4-FFF2-40B4-BE49-F238E27FC236}">
+                <a16:creationId xmlns:a16="http://schemas.microsoft.com/office/drawing/2014/main" id="{A2BD6CC8-010E-C75F-9045-58E249025B12}"/>
               </a:ext>
             </a:extLst>
           </p:cNvPr>
           <p:cNvCxnSpPr>
             <a:cxnSpLocks/>
-            <a:stCxn id="411" idx="3"/>
-            <a:endCxn id="207" idx="1"/>
+            <a:stCxn id="124" idx="1"/>
+            <a:endCxn id="203" idx="0"/>
           </p:cNvCxnSpPr>
           <p:nvPr/>
         </p:nvCxnSpPr>
         <p:spPr>
-          <a:xfrm flipH="1" flipV="1">
-            <a:off x="1411570" y="3931627"/>
-            <a:ext cx="1803569" cy="467399"/>
-          </a:xfrm>
-          <a:prstGeom prst="bentConnector5">
-            <a:avLst>
-              <a:gd name="adj1" fmla="val -6929"/>
-              <a:gd name="adj2" fmla="val 50000"/>
-              <a:gd name="adj3" fmla="val 107943"/>
-            </a:avLst>
+          <a:xfrm rot="10800000" flipV="1">
+            <a:off x="7101228" y="2096827"/>
+            <a:ext cx="133597" cy="1267539"/>
+          </a:xfrm>
+          <a:prstGeom prst="bentConnector2">
+            <a:avLst/>
           </a:prstGeom>
           <a:ln w="38100">
-            <a:tailEnd type="triangle"/>
+            <a:prstDash val="dash"/>
+            <a:headEnd type="triangle" w="med" len="med"/>
+            <a:tailEnd type="triangle" w="med" len="med"/>
           </a:ln>
         </p:spPr>
         <p:style>
@@ -9403,34 +8906,33 @@
       </p:cxnSp>
       <p:cxnSp>
         <p:nvCxnSpPr>
-          <p:cNvPr id="418" name="Elbow Connector 417">
-            <a:extLst>
-              <a:ext uri="{FF2B5EF4-FFF2-40B4-BE49-F238E27FC236}">
-                <a16:creationId xmlns:a16="http://schemas.microsoft.com/office/drawing/2014/main" id="{93D336B5-376D-08F8-7200-9DBE305EAF6C}"/>
+          <p:cNvPr id="318" name="Elbow Connector 317">
+            <a:extLst>
+              <a:ext uri="{FF2B5EF4-FFF2-40B4-BE49-F238E27FC236}">
+                <a16:creationId xmlns:a16="http://schemas.microsoft.com/office/drawing/2014/main" id="{F16A25D0-3C85-6841-BBF3-CF40983677B6}"/>
               </a:ext>
             </a:extLst>
           </p:cNvPr>
           <p:cNvCxnSpPr>
             <a:cxnSpLocks/>
-            <a:stCxn id="411" idx="3"/>
-            <a:endCxn id="10" idx="1"/>
+            <a:stCxn id="204" idx="3"/>
           </p:cNvCxnSpPr>
           <p:nvPr/>
         </p:nvCxnSpPr>
         <p:spPr>
-          <a:xfrm flipH="1" flipV="1">
-            <a:off x="959221" y="2509663"/>
-            <a:ext cx="2255918" cy="1889363"/>
-          </a:xfrm>
-          <a:prstGeom prst="bentConnector5">
+          <a:xfrm flipV="1">
+            <a:off x="3293181" y="3713482"/>
+            <a:ext cx="2726105" cy="364626"/>
+          </a:xfrm>
+          <a:prstGeom prst="bentConnector3">
             <a:avLst>
-              <a:gd name="adj1" fmla="val -10403"/>
-              <a:gd name="adj2" fmla="val 54517"/>
-              <a:gd name="adj3" fmla="val 115537"/>
+              <a:gd name="adj1" fmla="val 50000"/>
             </a:avLst>
           </a:prstGeom>
           <a:ln w="38100">
-            <a:tailEnd type="triangle"/>
+            <a:prstDash val="dash"/>
+            <a:headEnd type="none" w="med" len="med"/>
+            <a:tailEnd type="triangle" w="med" len="med"/>
           </a:ln>
         </p:spPr>
         <p:style>
@@ -9450,34 +8952,34 @@
       </p:cxnSp>
       <p:cxnSp>
         <p:nvCxnSpPr>
-          <p:cNvPr id="445" name="Elbow Connector 444">
-            <a:extLst>
-              <a:ext uri="{FF2B5EF4-FFF2-40B4-BE49-F238E27FC236}">
-                <a16:creationId xmlns:a16="http://schemas.microsoft.com/office/drawing/2014/main" id="{D401A50A-EE39-5ABB-0CC8-D3A02E1998A9}"/>
+          <p:cNvPr id="323" name="Elbow Connector 322">
+            <a:extLst>
+              <a:ext uri="{FF2B5EF4-FFF2-40B4-BE49-F238E27FC236}">
+                <a16:creationId xmlns:a16="http://schemas.microsoft.com/office/drawing/2014/main" id="{290FC449-2309-C9B3-D4D9-AD89940C3FDF}"/>
               </a:ext>
             </a:extLst>
           </p:cNvPr>
           <p:cNvCxnSpPr>
             <a:cxnSpLocks/>
-            <a:stCxn id="22" idx="0"/>
-            <a:endCxn id="25" idx="1"/>
+            <a:stCxn id="124" idx="3"/>
+            <a:endCxn id="289" idx="0"/>
           </p:cNvCxnSpPr>
           <p:nvPr/>
         </p:nvCxnSpPr>
         <p:spPr>
-          <a:xfrm rot="16200000" flipV="1">
-            <a:off x="488485" y="1426845"/>
-            <a:ext cx="2201669" cy="454763"/>
+          <a:xfrm flipH="1">
+            <a:off x="7190221" y="2096828"/>
+            <a:ext cx="2255307" cy="3425072"/>
           </a:xfrm>
           <a:prstGeom prst="bentConnector4">
             <a:avLst>
-              <a:gd name="adj1" fmla="val 2277"/>
-              <a:gd name="adj2" fmla="val 360806"/>
+              <a:gd name="adj1" fmla="val -7503"/>
+              <a:gd name="adj2" fmla="val 66294"/>
             </a:avLst>
           </a:prstGeom>
           <a:ln w="38100">
             <a:prstDash val="dash"/>
-            <a:headEnd type="none" w="med" len="med"/>
+            <a:headEnd type="triangle" w="med" len="med"/>
             <a:tailEnd type="triangle" w="med" len="med"/>
           </a:ln>
         </p:spPr>
@@ -9496,48 +8998,291 @@
           </a:fontRef>
         </p:style>
       </p:cxnSp>
-      <p:pic>
-        <p:nvPicPr>
-          <p:cNvPr id="23" name="Graphic 22" descr="Repeat with solid fill">
-            <a:extLst>
-              <a:ext uri="{FF2B5EF4-FFF2-40B4-BE49-F238E27FC236}">
-                <a16:creationId xmlns:a16="http://schemas.microsoft.com/office/drawing/2014/main" id="{09551D4D-6A79-39C2-445F-B6C40EAEA47E}"/>
-              </a:ext>
-            </a:extLst>
-          </p:cNvPr>
-          <p:cNvPicPr>
-            <a:picLocks noChangeAspect="1"/>
-          </p:cNvPicPr>
-          <p:nvPr/>
-        </p:nvPicPr>
-        <p:blipFill>
-          <a:blip r:embed="rId2">
-            <a:extLst>
-              <a:ext uri="{96DAC541-7B7A-43D3-8B79-37D633B846F1}">
-                <asvg:svgBlip xmlns:asvg="http://schemas.microsoft.com/office/drawing/2016/SVG/main" r:embed="rId3"/>
-              </a:ext>
-            </a:extLst>
-          </a:blip>
-          <a:stretch>
-            <a:fillRect/>
-          </a:stretch>
-        </p:blipFill>
-        <p:spPr>
-          <a:xfrm>
-            <a:off x="821257" y="2561410"/>
-            <a:ext cx="366563" cy="366563"/>
-          </a:xfrm>
-          <a:prstGeom prst="rect">
-            <a:avLst/>
-          </a:prstGeom>
-        </p:spPr>
-      </p:pic>
-      <p:sp>
-        <p:nvSpPr>
-          <p:cNvPr id="12" name="Rectangle 11">
-            <a:extLst>
-              <a:ext uri="{FF2B5EF4-FFF2-40B4-BE49-F238E27FC236}">
-                <a16:creationId xmlns:a16="http://schemas.microsoft.com/office/drawing/2014/main" id="{C8E75110-E5A2-86E9-F389-F50AFA3FB93B}"/>
+      <p:cxnSp>
+        <p:nvCxnSpPr>
+          <p:cNvPr id="330" name="Elbow Connector 329">
+            <a:extLst>
+              <a:ext uri="{FF2B5EF4-FFF2-40B4-BE49-F238E27FC236}">
+                <a16:creationId xmlns:a16="http://schemas.microsoft.com/office/drawing/2014/main" id="{D145EBC3-6A0E-CB95-C9FF-C8370282382E}"/>
+              </a:ext>
+            </a:extLst>
+          </p:cNvPr>
+          <p:cNvCxnSpPr>
+            <a:cxnSpLocks/>
+            <a:stCxn id="202" idx="2"/>
+            <a:endCxn id="289" idx="0"/>
+          </p:cNvCxnSpPr>
+          <p:nvPr/>
+        </p:nvCxnSpPr>
+        <p:spPr>
+          <a:xfrm rot="16200000" flipH="1">
+            <a:off x="6432051" y="4763730"/>
+            <a:ext cx="1471370" cy="44970"/>
+          </a:xfrm>
+          <a:prstGeom prst="bentConnector3">
+            <a:avLst>
+              <a:gd name="adj1" fmla="val 50000"/>
+            </a:avLst>
+          </a:prstGeom>
+          <a:ln w="38100">
+            <a:prstDash val="dash"/>
+            <a:headEnd type="triangle" w="med" len="med"/>
+            <a:tailEnd type="triangle" w="med" len="med"/>
+          </a:ln>
+        </p:spPr>
+        <p:style>
+          <a:lnRef idx="2">
+            <a:schemeClr val="dk1"/>
+          </a:lnRef>
+          <a:fillRef idx="0">
+            <a:schemeClr val="dk1"/>
+          </a:fillRef>
+          <a:effectRef idx="1">
+            <a:schemeClr val="dk1"/>
+          </a:effectRef>
+          <a:fontRef idx="minor">
+            <a:schemeClr val="tx1"/>
+          </a:fontRef>
+        </p:style>
+      </p:cxnSp>
+      <p:cxnSp>
+        <p:nvCxnSpPr>
+          <p:cNvPr id="334" name="Elbow Connector 333">
+            <a:extLst>
+              <a:ext uri="{FF2B5EF4-FFF2-40B4-BE49-F238E27FC236}">
+                <a16:creationId xmlns:a16="http://schemas.microsoft.com/office/drawing/2014/main" id="{760BFCB2-3D62-F50C-E73E-78B7EE7581DB}"/>
+              </a:ext>
+            </a:extLst>
+          </p:cNvPr>
+          <p:cNvCxnSpPr>
+            <a:cxnSpLocks/>
+            <a:stCxn id="204" idx="3"/>
+            <a:endCxn id="289" idx="1"/>
+          </p:cNvCxnSpPr>
+          <p:nvPr/>
+        </p:nvCxnSpPr>
+        <p:spPr>
+          <a:xfrm>
+            <a:off x="3293181" y="4078108"/>
+            <a:ext cx="3225795" cy="1780982"/>
+          </a:xfrm>
+          <a:prstGeom prst="bentConnector3">
+            <a:avLst>
+              <a:gd name="adj1" fmla="val 73140"/>
+            </a:avLst>
+          </a:prstGeom>
+          <a:ln w="38100">
+            <a:prstDash val="dash"/>
+            <a:headEnd type="none" w="med" len="med"/>
+            <a:tailEnd type="triangle" w="med" len="med"/>
+          </a:ln>
+        </p:spPr>
+        <p:style>
+          <a:lnRef idx="2">
+            <a:schemeClr val="dk1"/>
+          </a:lnRef>
+          <a:fillRef idx="0">
+            <a:schemeClr val="dk1"/>
+          </a:fillRef>
+          <a:effectRef idx="1">
+            <a:schemeClr val="dk1"/>
+          </a:effectRef>
+          <a:fontRef idx="minor">
+            <a:schemeClr val="tx1"/>
+          </a:fontRef>
+        </p:style>
+      </p:cxnSp>
+      <p:cxnSp>
+        <p:nvCxnSpPr>
+          <p:cNvPr id="341" name="Elbow Connector 340">
+            <a:extLst>
+              <a:ext uri="{FF2B5EF4-FFF2-40B4-BE49-F238E27FC236}">
+                <a16:creationId xmlns:a16="http://schemas.microsoft.com/office/drawing/2014/main" id="{24005D6A-4DC3-B548-8E21-828250BBEDDB}"/>
+              </a:ext>
+            </a:extLst>
+          </p:cNvPr>
+          <p:cNvCxnSpPr>
+            <a:cxnSpLocks/>
+            <a:stCxn id="289" idx="3"/>
+            <a:endCxn id="167" idx="1"/>
+          </p:cNvCxnSpPr>
+          <p:nvPr/>
+        </p:nvCxnSpPr>
+        <p:spPr>
+          <a:xfrm flipV="1">
+            <a:off x="7861465" y="5542150"/>
+            <a:ext cx="1975283" cy="316940"/>
+          </a:xfrm>
+          <a:prstGeom prst="bentConnector3">
+            <a:avLst>
+              <a:gd name="adj1" fmla="val 50000"/>
+            </a:avLst>
+          </a:prstGeom>
+          <a:ln w="38100">
+            <a:prstDash val="dash"/>
+            <a:headEnd type="none" w="med" len="med"/>
+            <a:tailEnd type="triangle" w="med" len="med"/>
+          </a:ln>
+        </p:spPr>
+        <p:style>
+          <a:lnRef idx="2">
+            <a:schemeClr val="dk1"/>
+          </a:lnRef>
+          <a:fillRef idx="0">
+            <a:schemeClr val="dk1"/>
+          </a:fillRef>
+          <a:effectRef idx="1">
+            <a:schemeClr val="dk1"/>
+          </a:effectRef>
+          <a:fontRef idx="minor">
+            <a:schemeClr val="tx1"/>
+          </a:fontRef>
+        </p:style>
+      </p:cxnSp>
+      <p:cxnSp>
+        <p:nvCxnSpPr>
+          <p:cNvPr id="344" name="Elbow Connector 343">
+            <a:extLst>
+              <a:ext uri="{FF2B5EF4-FFF2-40B4-BE49-F238E27FC236}">
+                <a16:creationId xmlns:a16="http://schemas.microsoft.com/office/drawing/2014/main" id="{2784287A-736E-68DE-209D-219212CEB8E3}"/>
+              </a:ext>
+            </a:extLst>
+          </p:cNvPr>
+          <p:cNvCxnSpPr>
+            <a:cxnSpLocks/>
+            <a:stCxn id="289" idx="3"/>
+            <a:endCxn id="228" idx="3"/>
+          </p:cNvCxnSpPr>
+          <p:nvPr/>
+        </p:nvCxnSpPr>
+        <p:spPr>
+          <a:xfrm flipH="1">
+            <a:off x="6019288" y="5859090"/>
+            <a:ext cx="1842177" cy="502003"/>
+          </a:xfrm>
+          <a:prstGeom prst="bentConnector3">
+            <a:avLst>
+              <a:gd name="adj1" fmla="val -12409"/>
+            </a:avLst>
+          </a:prstGeom>
+          <a:ln w="38100">
+            <a:prstDash val="dash"/>
+            <a:headEnd type="none" w="med" len="med"/>
+            <a:tailEnd type="triangle" w="med" len="med"/>
+          </a:ln>
+        </p:spPr>
+        <p:style>
+          <a:lnRef idx="2">
+            <a:schemeClr val="dk1"/>
+          </a:lnRef>
+          <a:fillRef idx="0">
+            <a:schemeClr val="dk1"/>
+          </a:fillRef>
+          <a:effectRef idx="1">
+            <a:schemeClr val="dk1"/>
+          </a:effectRef>
+          <a:fontRef idx="minor">
+            <a:schemeClr val="tx1"/>
+          </a:fontRef>
+        </p:style>
+      </p:cxnSp>
+      <p:cxnSp>
+        <p:nvCxnSpPr>
+          <p:cNvPr id="356" name="Elbow Connector 355">
+            <a:extLst>
+              <a:ext uri="{FF2B5EF4-FFF2-40B4-BE49-F238E27FC236}">
+                <a16:creationId xmlns:a16="http://schemas.microsoft.com/office/drawing/2014/main" id="{A0F63EF9-019B-28D7-1FF7-EABE30B73796}"/>
+              </a:ext>
+            </a:extLst>
+          </p:cNvPr>
+          <p:cNvCxnSpPr>
+            <a:cxnSpLocks/>
+            <a:stCxn id="151" idx="3"/>
+            <a:endCxn id="190" idx="3"/>
+          </p:cNvCxnSpPr>
+          <p:nvPr/>
+        </p:nvCxnSpPr>
+        <p:spPr>
+          <a:xfrm>
+            <a:off x="11412875" y="3314444"/>
+            <a:ext cx="57357" cy="3013978"/>
+          </a:xfrm>
+          <a:prstGeom prst="bentConnector3">
+            <a:avLst>
+              <a:gd name="adj1" fmla="val 498556"/>
+            </a:avLst>
+          </a:prstGeom>
+          <a:ln w="38100">
+            <a:tailEnd type="triangle"/>
+          </a:ln>
+        </p:spPr>
+        <p:style>
+          <a:lnRef idx="2">
+            <a:schemeClr val="dk1"/>
+          </a:lnRef>
+          <a:fillRef idx="0">
+            <a:schemeClr val="dk1"/>
+          </a:fillRef>
+          <a:effectRef idx="1">
+            <a:schemeClr val="dk1"/>
+          </a:effectRef>
+          <a:fontRef idx="minor">
+            <a:schemeClr val="tx1"/>
+          </a:fontRef>
+        </p:style>
+      </p:cxnSp>
+      <p:cxnSp>
+        <p:nvCxnSpPr>
+          <p:cNvPr id="361" name="Elbow Connector 360">
+            <a:extLst>
+              <a:ext uri="{FF2B5EF4-FFF2-40B4-BE49-F238E27FC236}">
+                <a16:creationId xmlns:a16="http://schemas.microsoft.com/office/drawing/2014/main" id="{F9AC13C7-350C-1DC2-5BDE-3F9AD781F1FD}"/>
+              </a:ext>
+            </a:extLst>
+          </p:cNvPr>
+          <p:cNvCxnSpPr>
+            <a:cxnSpLocks/>
+            <a:stCxn id="232" idx="2"/>
+            <a:endCxn id="172" idx="1"/>
+          </p:cNvCxnSpPr>
+          <p:nvPr/>
+        </p:nvCxnSpPr>
+        <p:spPr>
+          <a:xfrm rot="5400000" flipH="1" flipV="1">
+            <a:off x="6041092" y="2137041"/>
+            <a:ext cx="1287043" cy="7325090"/>
+          </a:xfrm>
+          <a:prstGeom prst="bentConnector4">
+            <a:avLst>
+              <a:gd name="adj1" fmla="val -4578"/>
+              <a:gd name="adj2" fmla="val 76531"/>
+            </a:avLst>
+          </a:prstGeom>
+          <a:ln w="38100">
+            <a:tailEnd type="triangle"/>
+          </a:ln>
+        </p:spPr>
+        <p:style>
+          <a:lnRef idx="2">
+            <a:schemeClr val="dk1"/>
+          </a:lnRef>
+          <a:fillRef idx="0">
+            <a:schemeClr val="dk1"/>
+          </a:fillRef>
+          <a:effectRef idx="1">
+            <a:schemeClr val="dk1"/>
+          </a:effectRef>
+          <a:fontRef idx="minor">
+            <a:schemeClr val="tx1"/>
+          </a:fontRef>
+        </p:style>
+      </p:cxnSp>
+      <p:sp>
+        <p:nvSpPr>
+          <p:cNvPr id="411" name="Rectangle 410">
+            <a:extLst>
+              <a:ext uri="{FF2B5EF4-FFF2-40B4-BE49-F238E27FC236}">
+                <a16:creationId xmlns:a16="http://schemas.microsoft.com/office/drawing/2014/main" id="{73015C36-0E66-77F0-222A-AF2B22DB0131}"/>
               </a:ext>
             </a:extLst>
           </p:cNvPr>
@@ -9546,7 +9291,7 @@
         </p:nvSpPr>
         <p:spPr>
           <a:xfrm>
-            <a:off x="2190654" y="6869131"/>
+            <a:off x="1416618" y="4260526"/>
             <a:ext cx="1798521" cy="276999"/>
           </a:xfrm>
           <a:prstGeom prst="rect">
@@ -9585,6 +9330,265 @@
       </p:sp>
       <p:sp>
         <p:nvSpPr>
+          <p:cNvPr id="412" name="TextBox 411">
+            <a:extLst>
+              <a:ext uri="{FF2B5EF4-FFF2-40B4-BE49-F238E27FC236}">
+                <a16:creationId xmlns:a16="http://schemas.microsoft.com/office/drawing/2014/main" id="{4B057196-5C1F-6BBE-C721-6AE09DC38A8F}"/>
+              </a:ext>
+            </a:extLst>
+          </p:cNvPr>
+          <p:cNvSpPr txBox="1"/>
+          <p:nvPr/>
+        </p:nvSpPr>
+        <p:spPr>
+          <a:xfrm>
+            <a:off x="1420935" y="4242051"/>
+            <a:ext cx="1721305" cy="276999"/>
+          </a:xfrm>
+          <a:prstGeom prst="rect">
+            <a:avLst/>
+          </a:prstGeom>
+          <a:noFill/>
+        </p:spPr>
+        <p:txBody>
+          <a:bodyPr wrap="none" rtlCol="0">
+            <a:spAutoFit/>
+          </a:bodyPr>
+          <a:lstStyle/>
+          <a:p>
+            <a:r>
+              <a:rPr lang="en-US" sz="1200" noProof="1"/>
+              <a:t>parameter files (config)</a:t>
+            </a:r>
+          </a:p>
+        </p:txBody>
+      </p:sp>
+      <p:cxnSp>
+        <p:nvCxnSpPr>
+          <p:cNvPr id="271" name="Elbow Connector 270">
+            <a:extLst>
+              <a:ext uri="{FF2B5EF4-FFF2-40B4-BE49-F238E27FC236}">
+                <a16:creationId xmlns:a16="http://schemas.microsoft.com/office/drawing/2014/main" id="{F1DCB39C-7841-7600-DE7A-8484CEBCFC65}"/>
+              </a:ext>
+            </a:extLst>
+          </p:cNvPr>
+          <p:cNvCxnSpPr>
+            <a:cxnSpLocks/>
+            <a:stCxn id="10" idx="0"/>
+            <a:endCxn id="235" idx="1"/>
+          </p:cNvCxnSpPr>
+          <p:nvPr/>
+        </p:nvCxnSpPr>
+        <p:spPr>
+          <a:xfrm rot="16200000" flipH="1">
+            <a:off x="-279414" y="4531717"/>
+            <a:ext cx="4636468" cy="315360"/>
+          </a:xfrm>
+          <a:prstGeom prst="bentConnector4">
+            <a:avLst>
+              <a:gd name="adj1" fmla="val -4108"/>
+              <a:gd name="adj2" fmla="val -644713"/>
+            </a:avLst>
+          </a:prstGeom>
+          <a:ln w="38100">
+            <a:tailEnd type="triangle"/>
+          </a:ln>
+        </p:spPr>
+        <p:style>
+          <a:lnRef idx="2">
+            <a:schemeClr val="dk1"/>
+          </a:lnRef>
+          <a:fillRef idx="0">
+            <a:schemeClr val="dk1"/>
+          </a:fillRef>
+          <a:effectRef idx="1">
+            <a:schemeClr val="dk1"/>
+          </a:effectRef>
+          <a:fontRef idx="minor">
+            <a:schemeClr val="tx1"/>
+          </a:fontRef>
+        </p:style>
+      </p:cxnSp>
+      <p:cxnSp>
+        <p:nvCxnSpPr>
+          <p:cNvPr id="413" name="Elbow Connector 412">
+            <a:extLst>
+              <a:ext uri="{FF2B5EF4-FFF2-40B4-BE49-F238E27FC236}">
+                <a16:creationId xmlns:a16="http://schemas.microsoft.com/office/drawing/2014/main" id="{A0C3B407-F4DE-374D-3AD3-97DFF9517D13}"/>
+              </a:ext>
+            </a:extLst>
+          </p:cNvPr>
+          <p:cNvCxnSpPr>
+            <a:cxnSpLocks/>
+            <a:stCxn id="411" idx="3"/>
+            <a:endCxn id="207" idx="1"/>
+          </p:cNvCxnSpPr>
+          <p:nvPr/>
+        </p:nvCxnSpPr>
+        <p:spPr>
+          <a:xfrm flipH="1" flipV="1">
+            <a:off x="1411570" y="3931627"/>
+            <a:ext cx="1803569" cy="467399"/>
+          </a:xfrm>
+          <a:prstGeom prst="bentConnector5">
+            <a:avLst>
+              <a:gd name="adj1" fmla="val -6929"/>
+              <a:gd name="adj2" fmla="val 50000"/>
+              <a:gd name="adj3" fmla="val 107943"/>
+            </a:avLst>
+          </a:prstGeom>
+          <a:ln w="38100">
+            <a:tailEnd type="triangle"/>
+          </a:ln>
+        </p:spPr>
+        <p:style>
+          <a:lnRef idx="2">
+            <a:schemeClr val="dk1"/>
+          </a:lnRef>
+          <a:fillRef idx="0">
+            <a:schemeClr val="dk1"/>
+          </a:fillRef>
+          <a:effectRef idx="1">
+            <a:schemeClr val="dk1"/>
+          </a:effectRef>
+          <a:fontRef idx="minor">
+            <a:schemeClr val="tx1"/>
+          </a:fontRef>
+        </p:style>
+      </p:cxnSp>
+      <p:cxnSp>
+        <p:nvCxnSpPr>
+          <p:cNvPr id="418" name="Elbow Connector 417">
+            <a:extLst>
+              <a:ext uri="{FF2B5EF4-FFF2-40B4-BE49-F238E27FC236}">
+                <a16:creationId xmlns:a16="http://schemas.microsoft.com/office/drawing/2014/main" id="{93D336B5-376D-08F8-7200-9DBE305EAF6C}"/>
+              </a:ext>
+            </a:extLst>
+          </p:cNvPr>
+          <p:cNvCxnSpPr>
+            <a:cxnSpLocks/>
+            <a:stCxn id="411" idx="3"/>
+            <a:endCxn id="10" idx="1"/>
+          </p:cNvCxnSpPr>
+          <p:nvPr/>
+        </p:nvCxnSpPr>
+        <p:spPr>
+          <a:xfrm flipH="1" flipV="1">
+            <a:off x="959221" y="2509663"/>
+            <a:ext cx="2255918" cy="1889363"/>
+          </a:xfrm>
+          <a:prstGeom prst="bentConnector5">
+            <a:avLst>
+              <a:gd name="adj1" fmla="val -10403"/>
+              <a:gd name="adj2" fmla="val 54517"/>
+              <a:gd name="adj3" fmla="val 115537"/>
+            </a:avLst>
+          </a:prstGeom>
+          <a:ln w="38100">
+            <a:tailEnd type="triangle"/>
+          </a:ln>
+        </p:spPr>
+        <p:style>
+          <a:lnRef idx="2">
+            <a:schemeClr val="dk1"/>
+          </a:lnRef>
+          <a:fillRef idx="0">
+            <a:schemeClr val="dk1"/>
+          </a:fillRef>
+          <a:effectRef idx="1">
+            <a:schemeClr val="dk1"/>
+          </a:effectRef>
+          <a:fontRef idx="minor">
+            <a:schemeClr val="tx1"/>
+          </a:fontRef>
+        </p:style>
+      </p:cxnSp>
+      <p:cxnSp>
+        <p:nvCxnSpPr>
+          <p:cNvPr id="445" name="Elbow Connector 444">
+            <a:extLst>
+              <a:ext uri="{FF2B5EF4-FFF2-40B4-BE49-F238E27FC236}">
+                <a16:creationId xmlns:a16="http://schemas.microsoft.com/office/drawing/2014/main" id="{D401A50A-EE39-5ABB-0CC8-D3A02E1998A9}"/>
+              </a:ext>
+            </a:extLst>
+          </p:cNvPr>
+          <p:cNvCxnSpPr>
+            <a:cxnSpLocks/>
+            <a:stCxn id="22" idx="0"/>
+            <a:endCxn id="25" idx="1"/>
+          </p:cNvCxnSpPr>
+          <p:nvPr/>
+        </p:nvCxnSpPr>
+        <p:spPr>
+          <a:xfrm rot="16200000" flipV="1">
+            <a:off x="488485" y="1426845"/>
+            <a:ext cx="2201669" cy="454763"/>
+          </a:xfrm>
+          <a:prstGeom prst="bentConnector4">
+            <a:avLst>
+              <a:gd name="adj1" fmla="val 2277"/>
+              <a:gd name="adj2" fmla="val 360806"/>
+            </a:avLst>
+          </a:prstGeom>
+          <a:ln w="38100">
+            <a:prstDash val="dash"/>
+            <a:headEnd type="none" w="med" len="med"/>
+            <a:tailEnd type="triangle" w="med" len="med"/>
+          </a:ln>
+        </p:spPr>
+        <p:style>
+          <a:lnRef idx="2">
+            <a:schemeClr val="dk1"/>
+          </a:lnRef>
+          <a:fillRef idx="0">
+            <a:schemeClr val="dk1"/>
+          </a:fillRef>
+          <a:effectRef idx="1">
+            <a:schemeClr val="dk1"/>
+          </a:effectRef>
+          <a:fontRef idx="minor">
+            <a:schemeClr val="tx1"/>
+          </a:fontRef>
+        </p:style>
+      </p:cxnSp>
+      <p:pic>
+        <p:nvPicPr>
+          <p:cNvPr id="23" name="Graphic 22" descr="Repeat with solid fill">
+            <a:extLst>
+              <a:ext uri="{FF2B5EF4-FFF2-40B4-BE49-F238E27FC236}">
+                <a16:creationId xmlns:a16="http://schemas.microsoft.com/office/drawing/2014/main" id="{09551D4D-6A79-39C2-445F-B6C40EAEA47E}"/>
+              </a:ext>
+            </a:extLst>
+          </p:cNvPr>
+          <p:cNvPicPr>
+            <a:picLocks noChangeAspect="1"/>
+          </p:cNvPicPr>
+          <p:nvPr/>
+        </p:nvPicPr>
+        <p:blipFill>
+          <a:blip>
+            <a:extLst>
+              <a:ext uri="{96DAC541-7B7A-43D3-8B79-37D633B846F1}">
+                <asvg:svgBlip xmlns:asvg="http://schemas.microsoft.com/office/drawing/2016/SVG/main" r:embed="rId2"/>
+              </a:ext>
+            </a:extLst>
+          </a:blip>
+          <a:stretch>
+            <a:fillRect/>
+          </a:stretch>
+        </p:blipFill>
+        <p:spPr>
+          <a:xfrm>
+            <a:off x="821257" y="2561410"/>
+            <a:ext cx="366563" cy="366563"/>
+          </a:xfrm>
+          <a:prstGeom prst="rect">
+            <a:avLst/>
+          </a:prstGeom>
+        </p:spPr>
+      </p:pic>
+      <p:sp>
+        <p:nvSpPr>
           <p:cNvPr id="3" name="TextBox 2">
             <a:extLst>
               <a:ext uri="{FF2B5EF4-FFF2-40B4-BE49-F238E27FC236}">
@@ -9597,7 +9601,7 @@
         </p:nvSpPr>
         <p:spPr>
           <a:xfrm>
-            <a:off x="2180997" y="6869131"/>
+            <a:off x="2197913" y="6555601"/>
             <a:ext cx="1366015" cy="276999"/>
           </a:xfrm>
           <a:prstGeom prst="rect">
@@ -9636,14 +9640,14 @@
         </p:nvCxnSpPr>
         <p:spPr>
           <a:xfrm flipH="1">
-            <a:off x="2180997" y="553392"/>
-            <a:ext cx="1024778" cy="6454239"/>
+            <a:off x="2197913" y="553392"/>
+            <a:ext cx="695708" cy="6140709"/>
           </a:xfrm>
           <a:prstGeom prst="bentConnector5">
             <a:avLst>
-              <a:gd name="adj1" fmla="val -3611"/>
-              <a:gd name="adj2" fmla="val 42309"/>
-              <a:gd name="adj3" fmla="val 195390"/>
+              <a:gd name="adj1" fmla="val -32859"/>
+              <a:gd name="adj2" fmla="val 42555"/>
+              <a:gd name="adj3" fmla="val 248777"/>
             </a:avLst>
           </a:prstGeom>
           <a:ln w="38100">
@@ -9752,6 +9756,58 @@
           </a:p>
         </p:txBody>
       </p:sp>
+      <p:sp>
+        <p:nvSpPr>
+          <p:cNvPr id="121" name="Rectangle 120">
+            <a:extLst>
+              <a:ext uri="{FF2B5EF4-FFF2-40B4-BE49-F238E27FC236}">
+                <a16:creationId xmlns:a16="http://schemas.microsoft.com/office/drawing/2014/main" id="{97D814AA-F7D5-5908-F53A-E39932D2141C}"/>
+              </a:ext>
+            </a:extLst>
+          </p:cNvPr>
+          <p:cNvSpPr/>
+          <p:nvPr/>
+        </p:nvSpPr>
+        <p:spPr>
+          <a:xfrm>
+            <a:off x="3411989" y="2202856"/>
+            <a:ext cx="1241246" cy="276998"/>
+          </a:xfrm>
+          <a:prstGeom prst="rect">
+            <a:avLst/>
+          </a:prstGeom>
+          <a:solidFill>
+            <a:schemeClr val="accent6">
+              <a:lumMod val="60000"/>
+              <a:lumOff val="40000"/>
+            </a:schemeClr>
+          </a:solidFill>
+        </p:spPr>
+        <p:style>
+          <a:lnRef idx="2">
+            <a:schemeClr val="accent1">
+              <a:shade val="15000"/>
+            </a:schemeClr>
+          </a:lnRef>
+          <a:fillRef idx="1">
+            <a:schemeClr val="accent1"/>
+          </a:fillRef>
+          <a:effectRef idx="0">
+            <a:schemeClr val="accent1"/>
+          </a:effectRef>
+          <a:fontRef idx="minor">
+            <a:schemeClr val="lt1"/>
+          </a:fontRef>
+        </p:style>
+        <p:txBody>
+          <a:bodyPr rtlCol="0" anchor="ctr"/>
+          <a:lstStyle/>
+          <a:p>
+            <a:pPr algn="ctr"/>
+            <a:endParaRPr lang="en-US" noProof="1"/>
+          </a:p>
+        </p:txBody>
+      </p:sp>
       <p:cxnSp>
         <p:nvCxnSpPr>
           <p:cNvPr id="16" name="Elbow Connector 15">
@@ -9775,7 +9831,351 @@
           </a:xfrm>
           <a:prstGeom prst="bentConnector3">
             <a:avLst>
-              <a:gd name="adj1" fmla="val 29924"/>
+              <a:gd name="adj1" fmla="val 32921"/>
+            </a:avLst>
+          </a:prstGeom>
+          <a:ln w="38100">
+            <a:tailEnd type="triangle"/>
+          </a:ln>
+        </p:spPr>
+        <p:style>
+          <a:lnRef idx="2">
+            <a:schemeClr val="dk1"/>
+          </a:lnRef>
+          <a:fillRef idx="0">
+            <a:schemeClr val="dk1"/>
+          </a:fillRef>
+          <a:effectRef idx="1">
+            <a:schemeClr val="dk1"/>
+          </a:effectRef>
+          <a:fontRef idx="minor">
+            <a:schemeClr val="tx1"/>
+          </a:fontRef>
+        </p:style>
+      </p:cxnSp>
+      <p:sp>
+        <p:nvSpPr>
+          <p:cNvPr id="122" name="Rectangle 121">
+            <a:extLst>
+              <a:ext uri="{FF2B5EF4-FFF2-40B4-BE49-F238E27FC236}">
+                <a16:creationId xmlns:a16="http://schemas.microsoft.com/office/drawing/2014/main" id="{51B08FE6-2245-C94B-E117-87B43E069B78}"/>
+              </a:ext>
+            </a:extLst>
+          </p:cNvPr>
+          <p:cNvSpPr/>
+          <p:nvPr/>
+        </p:nvSpPr>
+        <p:spPr>
+          <a:xfrm>
+            <a:off x="3551689" y="2515898"/>
+            <a:ext cx="763801" cy="276998"/>
+          </a:xfrm>
+          <a:prstGeom prst="rect">
+            <a:avLst/>
+          </a:prstGeom>
+          <a:solidFill>
+            <a:schemeClr val="accent6">
+              <a:lumMod val="60000"/>
+              <a:lumOff val="40000"/>
+            </a:schemeClr>
+          </a:solidFill>
+        </p:spPr>
+        <p:style>
+          <a:lnRef idx="2">
+            <a:schemeClr val="accent1">
+              <a:shade val="15000"/>
+            </a:schemeClr>
+          </a:lnRef>
+          <a:fillRef idx="1">
+            <a:schemeClr val="accent1"/>
+          </a:fillRef>
+          <a:effectRef idx="0">
+            <a:schemeClr val="accent1"/>
+          </a:effectRef>
+          <a:fontRef idx="minor">
+            <a:schemeClr val="lt1"/>
+          </a:fontRef>
+        </p:style>
+        <p:txBody>
+          <a:bodyPr rtlCol="0" anchor="ctr"/>
+          <a:lstStyle/>
+          <a:p>
+            <a:pPr algn="ctr"/>
+            <a:endParaRPr lang="en-US" noProof="1"/>
+          </a:p>
+        </p:txBody>
+      </p:sp>
+      <p:sp>
+        <p:nvSpPr>
+          <p:cNvPr id="88" name="TextBox 87">
+            <a:extLst>
+              <a:ext uri="{FF2B5EF4-FFF2-40B4-BE49-F238E27FC236}">
+                <a16:creationId xmlns:a16="http://schemas.microsoft.com/office/drawing/2014/main" id="{37C6E6D5-67F7-12E6-B1D9-95CD09C13167}"/>
+              </a:ext>
+            </a:extLst>
+          </p:cNvPr>
+          <p:cNvSpPr txBox="1"/>
+          <p:nvPr/>
+        </p:nvSpPr>
+        <p:spPr>
+          <a:xfrm>
+            <a:off x="3352524" y="2195514"/>
+            <a:ext cx="1463362" cy="276999"/>
+          </a:xfrm>
+          <a:prstGeom prst="rect">
+            <a:avLst/>
+          </a:prstGeom>
+          <a:noFill/>
+        </p:spPr>
+        <p:txBody>
+          <a:bodyPr wrap="square" rtlCol="0">
+            <a:spAutoFit/>
+          </a:bodyPr>
+          <a:lstStyle/>
+          <a:p>
+            <a:r>
+              <a:rPr lang="en-US" sz="1200" noProof="1"/>
+              <a:t>SNAP_preparation</a:t>
+            </a:r>
+          </a:p>
+        </p:txBody>
+      </p:sp>
+      <p:sp>
+        <p:nvSpPr>
+          <p:cNvPr id="89" name="TextBox 88">
+            <a:extLst>
+              <a:ext uri="{FF2B5EF4-FFF2-40B4-BE49-F238E27FC236}">
+                <a16:creationId xmlns:a16="http://schemas.microsoft.com/office/drawing/2014/main" id="{6E701B43-67D6-4BCC-7F61-319716C258F9}"/>
+              </a:ext>
+            </a:extLst>
+          </p:cNvPr>
+          <p:cNvSpPr txBox="1"/>
+          <p:nvPr/>
+        </p:nvSpPr>
+        <p:spPr>
+          <a:xfrm>
+            <a:off x="3526969" y="2523606"/>
+            <a:ext cx="1463362" cy="276999"/>
+          </a:xfrm>
+          <a:prstGeom prst="rect">
+            <a:avLst/>
+          </a:prstGeom>
+          <a:noFill/>
+        </p:spPr>
+        <p:txBody>
+          <a:bodyPr wrap="square" rtlCol="0">
+            <a:spAutoFit/>
+          </a:bodyPr>
+          <a:lstStyle/>
+          <a:p>
+            <a:r>
+              <a:rPr lang="en-US" sz="1200" noProof="1"/>
+              <a:t>SNAP_run</a:t>
+            </a:r>
+          </a:p>
+        </p:txBody>
+      </p:sp>
+      <p:sp>
+        <p:nvSpPr>
+          <p:cNvPr id="123" name="Rectangle 122">
+            <a:extLst>
+              <a:ext uri="{FF2B5EF4-FFF2-40B4-BE49-F238E27FC236}">
+                <a16:creationId xmlns:a16="http://schemas.microsoft.com/office/drawing/2014/main" id="{0C0EA210-7017-B2EF-0F0A-EF8AF29E5981}"/>
+              </a:ext>
+            </a:extLst>
+          </p:cNvPr>
+          <p:cNvSpPr/>
+          <p:nvPr/>
+        </p:nvSpPr>
+        <p:spPr>
+          <a:xfrm>
+            <a:off x="3550341" y="2826573"/>
+            <a:ext cx="1241246" cy="276998"/>
+          </a:xfrm>
+          <a:prstGeom prst="rect">
+            <a:avLst/>
+          </a:prstGeom>
+          <a:solidFill>
+            <a:schemeClr val="accent6">
+              <a:lumMod val="60000"/>
+              <a:lumOff val="40000"/>
+            </a:schemeClr>
+          </a:solidFill>
+        </p:spPr>
+        <p:style>
+          <a:lnRef idx="2">
+            <a:schemeClr val="accent1">
+              <a:shade val="15000"/>
+            </a:schemeClr>
+          </a:lnRef>
+          <a:fillRef idx="1">
+            <a:schemeClr val="accent1"/>
+          </a:fillRef>
+          <a:effectRef idx="0">
+            <a:schemeClr val="accent1"/>
+          </a:effectRef>
+          <a:fontRef idx="minor">
+            <a:schemeClr val="lt1"/>
+          </a:fontRef>
+        </p:style>
+        <p:txBody>
+          <a:bodyPr rtlCol="0" anchor="ctr"/>
+          <a:lstStyle/>
+          <a:p>
+            <a:pPr algn="ctr"/>
+            <a:endParaRPr lang="en-US" noProof="1"/>
+          </a:p>
+        </p:txBody>
+      </p:sp>
+      <p:sp>
+        <p:nvSpPr>
+          <p:cNvPr id="91" name="TextBox 90">
+            <a:extLst>
+              <a:ext uri="{FF2B5EF4-FFF2-40B4-BE49-F238E27FC236}">
+                <a16:creationId xmlns:a16="http://schemas.microsoft.com/office/drawing/2014/main" id="{0DA2E356-4F2E-D0EA-0E65-EB0DF862D3C7}"/>
+              </a:ext>
+            </a:extLst>
+          </p:cNvPr>
+          <p:cNvSpPr txBox="1"/>
+          <p:nvPr/>
+        </p:nvSpPr>
+        <p:spPr>
+          <a:xfrm>
+            <a:off x="3544603" y="2825056"/>
+            <a:ext cx="1463362" cy="276999"/>
+          </a:xfrm>
+          <a:prstGeom prst="rect">
+            <a:avLst/>
+          </a:prstGeom>
+          <a:noFill/>
+        </p:spPr>
+        <p:txBody>
+          <a:bodyPr wrap="square" rtlCol="0">
+            <a:spAutoFit/>
+          </a:bodyPr>
+          <a:lstStyle/>
+          <a:p>
+            <a:r>
+              <a:rPr lang="en-US" sz="1200" noProof="1"/>
+              <a:t>SNAP_cleanup</a:t>
+            </a:r>
+          </a:p>
+        </p:txBody>
+      </p:sp>
+      <p:cxnSp>
+        <p:nvCxnSpPr>
+          <p:cNvPr id="134" name="Elbow Connector 133">
+            <a:extLst>
+              <a:ext uri="{FF2B5EF4-FFF2-40B4-BE49-F238E27FC236}">
+                <a16:creationId xmlns:a16="http://schemas.microsoft.com/office/drawing/2014/main" id="{F53AB591-4C73-FA2B-608C-A825F264B04B}"/>
+              </a:ext>
+            </a:extLst>
+          </p:cNvPr>
+          <p:cNvCxnSpPr>
+            <a:cxnSpLocks/>
+            <a:stCxn id="121" idx="3"/>
+            <a:endCxn id="122" idx="3"/>
+          </p:cNvCxnSpPr>
+          <p:nvPr/>
+        </p:nvCxnSpPr>
+        <p:spPr>
+          <a:xfrm flipH="1">
+            <a:off x="4315490" y="2341355"/>
+            <a:ext cx="337745" cy="313042"/>
+          </a:xfrm>
+          <a:prstGeom prst="bentConnector3">
+            <a:avLst>
+              <a:gd name="adj1" fmla="val -20681"/>
+            </a:avLst>
+          </a:prstGeom>
+          <a:ln w="38100">
+            <a:tailEnd type="triangle"/>
+          </a:ln>
+        </p:spPr>
+        <p:style>
+          <a:lnRef idx="2">
+            <a:schemeClr val="dk1"/>
+          </a:lnRef>
+          <a:fillRef idx="0">
+            <a:schemeClr val="dk1"/>
+          </a:fillRef>
+          <a:effectRef idx="1">
+            <a:schemeClr val="dk1"/>
+          </a:effectRef>
+          <a:fontRef idx="minor">
+            <a:schemeClr val="tx1"/>
+          </a:fontRef>
+        </p:style>
+      </p:cxnSp>
+      <p:cxnSp>
+        <p:nvCxnSpPr>
+          <p:cNvPr id="142" name="Elbow Connector 141">
+            <a:extLst>
+              <a:ext uri="{FF2B5EF4-FFF2-40B4-BE49-F238E27FC236}">
+                <a16:creationId xmlns:a16="http://schemas.microsoft.com/office/drawing/2014/main" id="{8C0F00B3-FC42-AC4A-94F3-5FDB6FFB51C2}"/>
+              </a:ext>
+            </a:extLst>
+          </p:cNvPr>
+          <p:cNvCxnSpPr>
+            <a:cxnSpLocks/>
+            <a:stCxn id="122" idx="1"/>
+            <a:endCxn id="123" idx="1"/>
+          </p:cNvCxnSpPr>
+          <p:nvPr/>
+        </p:nvCxnSpPr>
+        <p:spPr>
+          <a:xfrm rot="10800000" flipV="1">
+            <a:off x="3550341" y="2654396"/>
+            <a:ext cx="1348" cy="310675"/>
+          </a:xfrm>
+          <a:prstGeom prst="bentConnector3">
+            <a:avLst>
+              <a:gd name="adj1" fmla="val 12818843"/>
+            </a:avLst>
+          </a:prstGeom>
+          <a:ln w="38100">
+            <a:tailEnd type="triangle"/>
+          </a:ln>
+        </p:spPr>
+        <p:style>
+          <a:lnRef idx="2">
+            <a:schemeClr val="dk1"/>
+          </a:lnRef>
+          <a:fillRef idx="0">
+            <a:schemeClr val="dk1"/>
+          </a:fillRef>
+          <a:effectRef idx="1">
+            <a:schemeClr val="dk1"/>
+          </a:effectRef>
+          <a:fontRef idx="minor">
+            <a:schemeClr val="tx1"/>
+          </a:fontRef>
+        </p:style>
+      </p:cxnSp>
+      <p:cxnSp>
+        <p:nvCxnSpPr>
+          <p:cNvPr id="162" name="Elbow Connector 161">
+            <a:extLst>
+              <a:ext uri="{FF2B5EF4-FFF2-40B4-BE49-F238E27FC236}">
+                <a16:creationId xmlns:a16="http://schemas.microsoft.com/office/drawing/2014/main" id="{AA2CABF4-A3D9-979F-2F50-4A3004A996E0}"/>
+              </a:ext>
+            </a:extLst>
+          </p:cNvPr>
+          <p:cNvCxnSpPr>
+            <a:cxnSpLocks/>
+            <a:stCxn id="9" idx="3"/>
+            <a:endCxn id="121" idx="1"/>
+          </p:cNvCxnSpPr>
+          <p:nvPr/>
+        </p:nvCxnSpPr>
+        <p:spPr>
+          <a:xfrm>
+            <a:off x="2030477" y="2013797"/>
+            <a:ext cx="1381512" cy="327558"/>
+          </a:xfrm>
+          <a:prstGeom prst="bentConnector3">
+            <a:avLst>
+              <a:gd name="adj1" fmla="val 57354"/>
             </a:avLst>
           </a:prstGeom>
           <a:ln w="38100">

</xml_diff>

<commit_message>
Switch to SNAP v13, SNAP now auto unzips
</commit_message>
<xml_diff>
--- a/docs/assets/Caroline_drawings.pptx
+++ b/docs/assets/Caroline_drawings.pptx
@@ -9989,8 +9989,8 @@
         </p:nvSpPr>
         <p:spPr>
           <a:xfrm>
-            <a:off x="3550341" y="2826573"/>
-            <a:ext cx="1241246" cy="276998"/>
+            <a:off x="3550340" y="2826573"/>
+            <a:ext cx="1414085" cy="276998"/>
           </a:xfrm>
           <a:prstGeom prst="rect">
             <a:avLst/>
@@ -10041,7 +10041,7 @@
         </p:nvSpPr>
         <p:spPr>
           <a:xfrm>
-            <a:off x="3544603" y="2825056"/>
+            <a:off x="3519257" y="2835895"/>
             <a:ext cx="1463362" cy="276999"/>
           </a:xfrm>
           <a:prstGeom prst="rect">
@@ -10057,7 +10057,7 @@
           <a:p>
             <a:r>
               <a:rPr lang="en-US" sz="1200" noProof="1"/>
-              <a:t>SNAP_cleanup</a:t>
+              <a:t>SNAP_permissions</a:t>
             </a:r>
           </a:p>
         </p:txBody>
@@ -10126,11 +10126,11 @@
         <p:spPr>
           <a:xfrm rot="10800000" flipV="1">
             <a:off x="3550341" y="2654396"/>
-            <a:ext cx="1348" cy="310675"/>
+            <a:ext cx="1349" cy="310675"/>
           </a:xfrm>
           <a:prstGeom prst="bentConnector3">
             <a:avLst>
-              <a:gd name="adj1" fmla="val 12818843"/>
+              <a:gd name="adj1" fmla="val 13787102"/>
             </a:avLst>
           </a:prstGeom>
           <a:ln w="38100">

</xml_diff>

<commit_message>
Update necessary sarxarray version, update architecture overview for znap_to_raw and znap_to_zarr
</commit_message>
<xml_diff>
--- a/docs/assets/Caroline_drawings.pptx
+++ b/docs/assets/Caroline_drawings.pptx
@@ -260,7 +260,7 @@
           <a:p>
             <a:fld id="{9BFBA175-CEA6-974F-BECD-C1A384BB3024}" type="datetimeFigureOut">
               <a:rPr lang="en-US" smtClean="0"/>
-              <a:t>3/30/26</a:t>
+              <a:t>8/3/26</a:t>
             </a:fld>
             <a:endParaRPr lang="en-US"/>
           </a:p>
@@ -458,7 +458,7 @@
           <a:p>
             <a:fld id="{9BFBA175-CEA6-974F-BECD-C1A384BB3024}" type="datetimeFigureOut">
               <a:rPr lang="en-US" smtClean="0"/>
-              <a:t>3/30/26</a:t>
+              <a:t>8/3/26</a:t>
             </a:fld>
             <a:endParaRPr lang="en-US"/>
           </a:p>
@@ -666,7 +666,7 @@
           <a:p>
             <a:fld id="{9BFBA175-CEA6-974F-BECD-C1A384BB3024}" type="datetimeFigureOut">
               <a:rPr lang="en-US" smtClean="0"/>
-              <a:t>3/30/26</a:t>
+              <a:t>8/3/26</a:t>
             </a:fld>
             <a:endParaRPr lang="en-US"/>
           </a:p>
@@ -864,7 +864,7 @@
           <a:p>
             <a:fld id="{9BFBA175-CEA6-974F-BECD-C1A384BB3024}" type="datetimeFigureOut">
               <a:rPr lang="en-US" smtClean="0"/>
-              <a:t>3/30/26</a:t>
+              <a:t>8/3/26</a:t>
             </a:fld>
             <a:endParaRPr lang="en-US"/>
           </a:p>
@@ -1139,7 +1139,7 @@
           <a:p>
             <a:fld id="{9BFBA175-CEA6-974F-BECD-C1A384BB3024}" type="datetimeFigureOut">
               <a:rPr lang="en-US" smtClean="0"/>
-              <a:t>3/30/26</a:t>
+              <a:t>8/3/26</a:t>
             </a:fld>
             <a:endParaRPr lang="en-US"/>
           </a:p>
@@ -1404,7 +1404,7 @@
           <a:p>
             <a:fld id="{9BFBA175-CEA6-974F-BECD-C1A384BB3024}" type="datetimeFigureOut">
               <a:rPr lang="en-US" smtClean="0"/>
-              <a:t>3/30/26</a:t>
+              <a:t>8/3/26</a:t>
             </a:fld>
             <a:endParaRPr lang="en-US"/>
           </a:p>
@@ -1816,7 +1816,7 @@
           <a:p>
             <a:fld id="{9BFBA175-CEA6-974F-BECD-C1A384BB3024}" type="datetimeFigureOut">
               <a:rPr lang="en-US" smtClean="0"/>
-              <a:t>3/30/26</a:t>
+              <a:t>8/3/26</a:t>
             </a:fld>
             <a:endParaRPr lang="en-US"/>
           </a:p>
@@ -1957,7 +1957,7 @@
           <a:p>
             <a:fld id="{9BFBA175-CEA6-974F-BECD-C1A384BB3024}" type="datetimeFigureOut">
               <a:rPr lang="en-US" smtClean="0"/>
-              <a:t>3/30/26</a:t>
+              <a:t>8/3/26</a:t>
             </a:fld>
             <a:endParaRPr lang="en-US"/>
           </a:p>
@@ -2070,7 +2070,7 @@
           <a:p>
             <a:fld id="{9BFBA175-CEA6-974F-BECD-C1A384BB3024}" type="datetimeFigureOut">
               <a:rPr lang="en-US" smtClean="0"/>
-              <a:t>3/30/26</a:t>
+              <a:t>8/3/26</a:t>
             </a:fld>
             <a:endParaRPr lang="en-US"/>
           </a:p>
@@ -2381,7 +2381,7 @@
           <a:p>
             <a:fld id="{9BFBA175-CEA6-974F-BECD-C1A384BB3024}" type="datetimeFigureOut">
               <a:rPr lang="en-US" smtClean="0"/>
-              <a:t>3/30/26</a:t>
+              <a:t>8/3/26</a:t>
             </a:fld>
             <a:endParaRPr lang="en-US"/>
           </a:p>
@@ -2669,7 +2669,7 @@
           <a:p>
             <a:fld id="{9BFBA175-CEA6-974F-BECD-C1A384BB3024}" type="datetimeFigureOut">
               <a:rPr lang="en-US" smtClean="0"/>
-              <a:t>3/30/26</a:t>
+              <a:t>8/3/26</a:t>
             </a:fld>
             <a:endParaRPr lang="en-US"/>
           </a:p>
@@ -2910,7 +2910,7 @@
           <a:p>
             <a:fld id="{9BFBA175-CEA6-974F-BECD-C1A384BB3024}" type="datetimeFigureOut">
               <a:rPr lang="en-US" smtClean="0"/>
-              <a:t>3/30/26</a:t>
+              <a:t>8/3/26</a:t>
             </a:fld>
             <a:endParaRPr lang="en-US"/>
           </a:p>
@@ -4661,8 +4661,8 @@
         </p:nvSpPr>
         <p:spPr>
           <a:xfrm>
-            <a:off x="5185847" y="1423746"/>
-            <a:ext cx="1335208" cy="1607580"/>
+            <a:off x="5185847" y="1132898"/>
+            <a:ext cx="1335208" cy="2036292"/>
           </a:xfrm>
           <a:prstGeom prst="rect">
             <a:avLst/>
@@ -4713,7 +4713,7 @@
         </p:nvSpPr>
         <p:spPr>
           <a:xfrm>
-            <a:off x="5276654" y="1871922"/>
+            <a:off x="5276654" y="1585597"/>
             <a:ext cx="1135096" cy="276998"/>
           </a:xfrm>
           <a:prstGeom prst="rect">
@@ -4765,7 +4765,7 @@
         </p:nvSpPr>
         <p:spPr>
           <a:xfrm>
-            <a:off x="5255827" y="1876997"/>
+            <a:off x="5273624" y="1581451"/>
             <a:ext cx="1155923" cy="276999"/>
           </a:xfrm>
           <a:prstGeom prst="rect">
@@ -4800,8 +4800,8 @@
         </p:nvSpPr>
         <p:spPr>
           <a:xfrm>
-            <a:off x="5203011" y="1424514"/>
-            <a:ext cx="944489" cy="461665"/>
+            <a:off x="5182572" y="1141614"/>
+            <a:ext cx="1698868" cy="461665"/>
           </a:xfrm>
           <a:prstGeom prst="rect">
             <a:avLst/>
@@ -4809,14 +4809,14 @@
           <a:noFill/>
         </p:spPr>
         <p:txBody>
-          <a:bodyPr wrap="none" rtlCol="0">
+          <a:bodyPr wrap="square" rtlCol="0">
             <a:spAutoFit/>
           </a:bodyPr>
           <a:lstStyle/>
           <a:p>
             <a:r>
               <a:rPr lang="en-US" sz="1200" noProof="1"/>
-              <a:t>Cropping</a:t>
+              <a:t>Cropping </a:t>
             </a:r>
           </a:p>
           <a:p>
@@ -4841,7 +4841,7 @@
         </p:nvSpPr>
         <p:spPr>
           <a:xfrm>
-            <a:off x="5278701" y="2255705"/>
+            <a:off x="5278700" y="1946319"/>
             <a:ext cx="1145770" cy="276998"/>
           </a:xfrm>
           <a:prstGeom prst="rect">
@@ -4893,7 +4893,7 @@
         </p:nvSpPr>
         <p:spPr>
           <a:xfrm>
-            <a:off x="5275043" y="2273990"/>
+            <a:off x="5266631" y="1933602"/>
             <a:ext cx="1022204" cy="276999"/>
           </a:xfrm>
           <a:prstGeom prst="rect">
@@ -4933,11 +4933,11 @@
         <p:spPr>
           <a:xfrm>
             <a:off x="4088586" y="1656672"/>
-            <a:ext cx="1167241" cy="358825"/>
+            <a:ext cx="1185038" cy="63279"/>
           </a:xfrm>
           <a:prstGeom prst="bentConnector3">
             <a:avLst>
-              <a:gd name="adj1" fmla="val 84817"/>
+              <a:gd name="adj1" fmla="val 50000"/>
             </a:avLst>
           </a:prstGeom>
           <a:ln w="38100">
@@ -4978,11 +4978,11 @@
         <p:spPr>
           <a:xfrm>
             <a:off x="4088586" y="1656672"/>
-            <a:ext cx="1186457" cy="755818"/>
+            <a:ext cx="1178045" cy="415430"/>
           </a:xfrm>
           <a:prstGeom prst="bentConnector3">
             <a:avLst>
-              <a:gd name="adj1" fmla="val 69267"/>
+              <a:gd name="adj1" fmla="val 42944"/>
             </a:avLst>
           </a:prstGeom>
           <a:ln w="38100">
@@ -5021,13 +5021,13 @@
           <p:nvPr/>
         </p:nvCxnSpPr>
         <p:spPr>
-          <a:xfrm>
-            <a:off x="4180789" y="1997295"/>
-            <a:ext cx="1075038" cy="18202"/>
+          <a:xfrm flipV="1">
+            <a:off x="4180789" y="1719951"/>
+            <a:ext cx="1092835" cy="277344"/>
           </a:xfrm>
           <a:prstGeom prst="bentConnector3">
             <a:avLst>
-              <a:gd name="adj1" fmla="val 57679"/>
+              <a:gd name="adj1" fmla="val 67749"/>
             </a:avLst>
           </a:prstGeom>
           <a:ln w="38100">
@@ -5068,11 +5068,11 @@
         <p:spPr>
           <a:xfrm>
             <a:off x="4180789" y="1997295"/>
-            <a:ext cx="1094254" cy="415195"/>
+            <a:ext cx="1085842" cy="74807"/>
           </a:xfrm>
           <a:prstGeom prst="bentConnector3">
             <a:avLst>
-              <a:gd name="adj1" fmla="val 56383"/>
+              <a:gd name="adj1" fmla="val 12573"/>
             </a:avLst>
           </a:prstGeom>
           <a:ln w="38100">
@@ -5742,7 +5742,7 @@
         <p:spPr>
           <a:xfrm rot="10800000" flipV="1">
             <a:off x="5853452" y="423098"/>
-            <a:ext cx="1042863" cy="1000647"/>
+            <a:ext cx="1042863" cy="709799"/>
           </a:xfrm>
           <a:prstGeom prst="bentConnector2">
             <a:avLst/>
@@ -6055,12 +6055,12 @@
         </p:nvCxnSpPr>
         <p:spPr>
           <a:xfrm>
-            <a:off x="6411750" y="2015497"/>
-            <a:ext cx="1341788" cy="408756"/>
+            <a:off x="6429547" y="1719951"/>
+            <a:ext cx="1323991" cy="704302"/>
           </a:xfrm>
           <a:prstGeom prst="bentConnector3">
             <a:avLst>
-              <a:gd name="adj1" fmla="val 39589"/>
+              <a:gd name="adj1" fmla="val 43721"/>
             </a:avLst>
           </a:prstGeom>
           <a:ln w="38100">
@@ -9826,12 +9826,12 @@
         </p:nvCxnSpPr>
         <p:spPr>
           <a:xfrm>
-            <a:off x="6424471" y="2394204"/>
-            <a:ext cx="1301312" cy="383150"/>
+            <a:off x="6424470" y="2084818"/>
+            <a:ext cx="1301313" cy="692536"/>
           </a:xfrm>
           <a:prstGeom prst="bentConnector3">
             <a:avLst>
-              <a:gd name="adj1" fmla="val 32921"/>
+              <a:gd name="adj1" fmla="val 35095"/>
             </a:avLst>
           </a:prstGeom>
           <a:ln w="38100">
@@ -10176,6 +10176,360 @@
           <a:prstGeom prst="bentConnector3">
             <a:avLst>
               <a:gd name="adj1" fmla="val 57354"/>
+            </a:avLst>
+          </a:prstGeom>
+          <a:ln w="38100">
+            <a:tailEnd type="triangle"/>
+          </a:ln>
+        </p:spPr>
+        <p:style>
+          <a:lnRef idx="2">
+            <a:schemeClr val="dk1"/>
+          </a:lnRef>
+          <a:fillRef idx="0">
+            <a:schemeClr val="dk1"/>
+          </a:fillRef>
+          <a:effectRef idx="1">
+            <a:schemeClr val="dk1"/>
+          </a:effectRef>
+          <a:fontRef idx="minor">
+            <a:schemeClr val="tx1"/>
+          </a:fontRef>
+        </p:style>
+      </p:cxnSp>
+      <p:sp>
+        <p:nvSpPr>
+          <p:cNvPr id="27" name="Rectangle 26">
+            <a:extLst>
+              <a:ext uri="{FF2B5EF4-FFF2-40B4-BE49-F238E27FC236}">
+                <a16:creationId xmlns:a16="http://schemas.microsoft.com/office/drawing/2014/main" id="{4BFD2C19-2A0D-A0E4-3F3E-B4FA266FE1E5}"/>
+              </a:ext>
+            </a:extLst>
+          </p:cNvPr>
+          <p:cNvSpPr/>
+          <p:nvPr/>
+        </p:nvSpPr>
+        <p:spPr>
+          <a:xfrm>
+            <a:off x="5283232" y="2329638"/>
+            <a:ext cx="1136707" cy="276998"/>
+          </a:xfrm>
+          <a:prstGeom prst="rect">
+            <a:avLst/>
+          </a:prstGeom>
+          <a:solidFill>
+            <a:schemeClr val="accent6">
+              <a:lumMod val="60000"/>
+              <a:lumOff val="40000"/>
+            </a:schemeClr>
+          </a:solidFill>
+        </p:spPr>
+        <p:style>
+          <a:lnRef idx="2">
+            <a:schemeClr val="accent1">
+              <a:shade val="15000"/>
+            </a:schemeClr>
+          </a:lnRef>
+          <a:fillRef idx="1">
+            <a:schemeClr val="accent1"/>
+          </a:fillRef>
+          <a:effectRef idx="0">
+            <a:schemeClr val="accent1"/>
+          </a:effectRef>
+          <a:fontRef idx="minor">
+            <a:schemeClr val="lt1"/>
+          </a:fontRef>
+        </p:style>
+        <p:txBody>
+          <a:bodyPr rtlCol="0" anchor="ctr"/>
+          <a:lstStyle/>
+          <a:p>
+            <a:pPr algn="ctr"/>
+            <a:endParaRPr lang="en-US" noProof="1"/>
+          </a:p>
+        </p:txBody>
+      </p:sp>
+      <p:sp>
+        <p:nvSpPr>
+          <p:cNvPr id="19" name="TextBox 18">
+            <a:extLst>
+              <a:ext uri="{FF2B5EF4-FFF2-40B4-BE49-F238E27FC236}">
+                <a16:creationId xmlns:a16="http://schemas.microsoft.com/office/drawing/2014/main" id="{D1B200E0-B934-C795-EF76-01BF02764698}"/>
+              </a:ext>
+            </a:extLst>
+          </p:cNvPr>
+          <p:cNvSpPr txBox="1"/>
+          <p:nvPr/>
+        </p:nvSpPr>
+        <p:spPr>
+          <a:xfrm>
+            <a:off x="5276379" y="2319061"/>
+            <a:ext cx="1155923" cy="276999"/>
+          </a:xfrm>
+          <a:prstGeom prst="rect">
+            <a:avLst/>
+          </a:prstGeom>
+          <a:noFill/>
+        </p:spPr>
+        <p:txBody>
+          <a:bodyPr wrap="square" rtlCol="0">
+            <a:spAutoFit/>
+          </a:bodyPr>
+          <a:lstStyle/>
+          <a:p>
+            <a:r>
+              <a:rPr lang="en-US" sz="1200" noProof="1"/>
+              <a:t>znap_to_raw</a:t>
+            </a:r>
+          </a:p>
+        </p:txBody>
+      </p:sp>
+      <p:sp>
+        <p:nvSpPr>
+          <p:cNvPr id="29" name="Rectangle 28">
+            <a:extLst>
+              <a:ext uri="{FF2B5EF4-FFF2-40B4-BE49-F238E27FC236}">
+                <a16:creationId xmlns:a16="http://schemas.microsoft.com/office/drawing/2014/main" id="{3F3B2E86-BC18-C082-99CB-5ACF49CC0923}"/>
+              </a:ext>
+            </a:extLst>
+          </p:cNvPr>
+          <p:cNvSpPr/>
+          <p:nvPr/>
+        </p:nvSpPr>
+        <p:spPr>
+          <a:xfrm>
+            <a:off x="5283231" y="2699646"/>
+            <a:ext cx="1136707" cy="276998"/>
+          </a:xfrm>
+          <a:prstGeom prst="rect">
+            <a:avLst/>
+          </a:prstGeom>
+          <a:solidFill>
+            <a:schemeClr val="accent6">
+              <a:lumMod val="60000"/>
+              <a:lumOff val="40000"/>
+            </a:schemeClr>
+          </a:solidFill>
+        </p:spPr>
+        <p:style>
+          <a:lnRef idx="2">
+            <a:schemeClr val="accent1">
+              <a:shade val="15000"/>
+            </a:schemeClr>
+          </a:lnRef>
+          <a:fillRef idx="1">
+            <a:schemeClr val="accent1"/>
+          </a:fillRef>
+          <a:effectRef idx="0">
+            <a:schemeClr val="accent1"/>
+          </a:effectRef>
+          <a:fontRef idx="minor">
+            <a:schemeClr val="lt1"/>
+          </a:fontRef>
+        </p:style>
+        <p:txBody>
+          <a:bodyPr rtlCol="0" anchor="ctr"/>
+          <a:lstStyle/>
+          <a:p>
+            <a:pPr algn="ctr"/>
+            <a:endParaRPr lang="en-US" noProof="1"/>
+          </a:p>
+        </p:txBody>
+      </p:sp>
+      <p:sp>
+        <p:nvSpPr>
+          <p:cNvPr id="46" name="TextBox 45">
+            <a:extLst>
+              <a:ext uri="{FF2B5EF4-FFF2-40B4-BE49-F238E27FC236}">
+                <a16:creationId xmlns:a16="http://schemas.microsoft.com/office/drawing/2014/main" id="{D17A9E61-E95A-FE29-01A6-E1A166DA0F3D}"/>
+              </a:ext>
+            </a:extLst>
+          </p:cNvPr>
+          <p:cNvSpPr txBox="1"/>
+          <p:nvPr/>
+        </p:nvSpPr>
+        <p:spPr>
+          <a:xfrm>
+            <a:off x="5262805" y="2708881"/>
+            <a:ext cx="1155923" cy="276999"/>
+          </a:xfrm>
+          <a:prstGeom prst="rect">
+            <a:avLst/>
+          </a:prstGeom>
+          <a:noFill/>
+        </p:spPr>
+        <p:txBody>
+          <a:bodyPr wrap="square" rtlCol="0">
+            <a:spAutoFit/>
+          </a:bodyPr>
+          <a:lstStyle/>
+          <a:p>
+            <a:r>
+              <a:rPr lang="en-US" sz="1200" noProof="1"/>
+              <a:t>znap_to_zarr</a:t>
+            </a:r>
+          </a:p>
+        </p:txBody>
+      </p:sp>
+      <p:cxnSp>
+        <p:nvCxnSpPr>
+          <p:cNvPr id="54" name="Elbow Connector 53">
+            <a:extLst>
+              <a:ext uri="{FF2B5EF4-FFF2-40B4-BE49-F238E27FC236}">
+                <a16:creationId xmlns:a16="http://schemas.microsoft.com/office/drawing/2014/main" id="{0ECBA00F-FF95-B4CE-7AD7-306A53CA5AE6}"/>
+              </a:ext>
+            </a:extLst>
+          </p:cNvPr>
+          <p:cNvCxnSpPr>
+            <a:cxnSpLocks/>
+            <a:stCxn id="91" idx="3"/>
+            <a:endCxn id="19" idx="1"/>
+          </p:cNvCxnSpPr>
+          <p:nvPr/>
+        </p:nvCxnSpPr>
+        <p:spPr>
+          <a:xfrm flipV="1">
+            <a:off x="4982619" y="2457561"/>
+            <a:ext cx="293760" cy="516834"/>
+          </a:xfrm>
+          <a:prstGeom prst="bentConnector3">
+            <a:avLst>
+              <a:gd name="adj1" fmla="val 34279"/>
+            </a:avLst>
+          </a:prstGeom>
+          <a:ln w="38100">
+            <a:tailEnd type="triangle"/>
+          </a:ln>
+        </p:spPr>
+        <p:style>
+          <a:lnRef idx="2">
+            <a:schemeClr val="dk1"/>
+          </a:lnRef>
+          <a:fillRef idx="0">
+            <a:schemeClr val="dk1"/>
+          </a:fillRef>
+          <a:effectRef idx="1">
+            <a:schemeClr val="dk1"/>
+          </a:effectRef>
+          <a:fontRef idx="minor">
+            <a:schemeClr val="tx1"/>
+          </a:fontRef>
+        </p:style>
+      </p:cxnSp>
+      <p:cxnSp>
+        <p:nvCxnSpPr>
+          <p:cNvPr id="59" name="Elbow Connector 58">
+            <a:extLst>
+              <a:ext uri="{FF2B5EF4-FFF2-40B4-BE49-F238E27FC236}">
+                <a16:creationId xmlns:a16="http://schemas.microsoft.com/office/drawing/2014/main" id="{4CA5B25A-2D41-6F5A-C1CF-97A4B4EA9F18}"/>
+              </a:ext>
+            </a:extLst>
+          </p:cNvPr>
+          <p:cNvCxnSpPr>
+            <a:cxnSpLocks/>
+            <a:stCxn id="91" idx="3"/>
+            <a:endCxn id="46" idx="1"/>
+          </p:cNvCxnSpPr>
+          <p:nvPr/>
+        </p:nvCxnSpPr>
+        <p:spPr>
+          <a:xfrm flipV="1">
+            <a:off x="4982619" y="2847381"/>
+            <a:ext cx="280186" cy="127014"/>
+          </a:xfrm>
+          <a:prstGeom prst="bentConnector3">
+            <a:avLst>
+              <a:gd name="adj1" fmla="val 36814"/>
+            </a:avLst>
+          </a:prstGeom>
+          <a:ln w="38100">
+            <a:tailEnd type="triangle"/>
+          </a:ln>
+        </p:spPr>
+        <p:style>
+          <a:lnRef idx="2">
+            <a:schemeClr val="dk1"/>
+          </a:lnRef>
+          <a:fillRef idx="0">
+            <a:schemeClr val="dk1"/>
+          </a:fillRef>
+          <a:effectRef idx="1">
+            <a:schemeClr val="dk1"/>
+          </a:effectRef>
+          <a:fontRef idx="minor">
+            <a:schemeClr val="tx1"/>
+          </a:fontRef>
+        </p:style>
+      </p:cxnSp>
+      <p:cxnSp>
+        <p:nvCxnSpPr>
+          <p:cNvPr id="63" name="Elbow Connector 62">
+            <a:extLst>
+              <a:ext uri="{FF2B5EF4-FFF2-40B4-BE49-F238E27FC236}">
+                <a16:creationId xmlns:a16="http://schemas.microsoft.com/office/drawing/2014/main" id="{C88B3916-945F-7C75-1625-B41EE9067B5B}"/>
+              </a:ext>
+            </a:extLst>
+          </p:cNvPr>
+          <p:cNvCxnSpPr>
+            <a:cxnSpLocks/>
+            <a:stCxn id="46" idx="3"/>
+            <a:endCxn id="14" idx="1"/>
+          </p:cNvCxnSpPr>
+          <p:nvPr/>
+        </p:nvCxnSpPr>
+        <p:spPr>
+          <a:xfrm flipV="1">
+            <a:off x="6418728" y="2777354"/>
+            <a:ext cx="1307055" cy="70027"/>
+          </a:xfrm>
+          <a:prstGeom prst="bentConnector3">
+            <a:avLst>
+              <a:gd name="adj1" fmla="val 42933"/>
+            </a:avLst>
+          </a:prstGeom>
+          <a:ln w="38100">
+            <a:tailEnd type="triangle"/>
+          </a:ln>
+        </p:spPr>
+        <p:style>
+          <a:lnRef idx="2">
+            <a:schemeClr val="dk1"/>
+          </a:lnRef>
+          <a:fillRef idx="0">
+            <a:schemeClr val="dk1"/>
+          </a:fillRef>
+          <a:effectRef idx="1">
+            <a:schemeClr val="dk1"/>
+          </a:effectRef>
+          <a:fontRef idx="minor">
+            <a:schemeClr val="tx1"/>
+          </a:fontRef>
+        </p:style>
+      </p:cxnSp>
+      <p:cxnSp>
+        <p:nvCxnSpPr>
+          <p:cNvPr id="73" name="Elbow Connector 72">
+            <a:extLst>
+              <a:ext uri="{FF2B5EF4-FFF2-40B4-BE49-F238E27FC236}">
+                <a16:creationId xmlns:a16="http://schemas.microsoft.com/office/drawing/2014/main" id="{1B1ABF9F-0B05-989B-B33D-04C4A92083CC}"/>
+              </a:ext>
+            </a:extLst>
+          </p:cNvPr>
+          <p:cNvCxnSpPr>
+            <a:cxnSpLocks/>
+            <a:stCxn id="19" idx="3"/>
+            <a:endCxn id="130" idx="1"/>
+          </p:cNvCxnSpPr>
+          <p:nvPr/>
+        </p:nvCxnSpPr>
+        <p:spPr>
+          <a:xfrm flipV="1">
+            <a:off x="6432302" y="2424253"/>
+            <a:ext cx="1321236" cy="33308"/>
+          </a:xfrm>
+          <a:prstGeom prst="bentConnector3">
+            <a:avLst>
+              <a:gd name="adj1" fmla="val 15047"/>
             </a:avLst>
           </a:prstGeom>
           <a:ln w="38100">

</xml_diff>